<commit_message>
Recherche eingearbeitet: geprüfte Werke, korrigierte Daten, Quellen und Bildnachweise
Co-Authored-By: Claude Opus 5.5 <noreply@anthropic.com>
Claude-Session: https://claude.ai/code/session_01XKdu8uiUBwzdSo25VMnQHA
</commit_message>
<xml_diff>
--- a/Fotorealismus_Hyperrealismus.pptx
+++ b/Fotorealismus_Hyperrealismus.pptx
@@ -126,20 +126,20 @@
   <p:extLst>
     <p:ext uri="{521415D9-36F7-43E2-AB2F-B90AF26B5E84}">
       <p14:sectionLst xmlns:p14="http://schemas.microsoft.com/office/powerpoint/2010/main">
-        <p14:section name="Einstieg" id="{53667f77-bd9c-6235-82e8-27ba2e792c5b}">
+        <p14:section name="Einstieg" id="{65bac779-7938-741b-26ea-076d2d4e8b94}">
           <p14:sldIdLst>
             <p14:sldId id="256"/>
             <p14:sldId id="257"/>
             <p14:sldId id="258"/>
           </p14:sldIdLst>
         </p14:section>
-        <p14:section name="Zeitliche Einordnung" id="{7395800b-0088-c351-4926-1f7a414ade39}">
+        <p14:section name="Zeitliche Einordnung" id="{7df43458-8435-b4b2-9938-5264f48f919e}">
           <p14:sldIdLst>
             <p14:sldId id="259"/>
             <p14:sldId id="260"/>
           </p14:sldIdLst>
         </p14:section>
-        <p14:section name="Merkmale" id="{4a0ba526-5475-c97b-5171-12f09957a41f}">
+        <p14:section name="Merkmale" id="{c2147c89-55e6-627d-82ca-56822568a317}">
           <p14:sldIdLst>
             <p14:sldId id="261"/>
             <p14:sldId id="262"/>
@@ -147,18 +147,18 @@
             <p14:sldId id="264"/>
           </p14:sldIdLst>
         </p14:section>
-        <p14:section name="Motive" id="{a307d6eb-9389-5fb3-7d85-4ba3fb149daa}">
+        <p14:section name="Motive" id="{69b003f3-dde4-cb12-d433-7553ab742b72}">
           <p14:sldIdLst>
             <p14:sldId id="265"/>
           </p14:sldIdLst>
         </p14:section>
-        <p14:section name="Hauptvertreter" id="{683ed24a-1fe4-25e1-17c5-bcc12db2eb6f}">
+        <p14:section name="Hauptvertreter" id="{7a7b0aff-7684-c10d-4f9a-4081ceb7afee}">
           <p14:sldIdLst>
             <p14:sldId id="266"/>
             <p14:sldId id="267"/>
           </p14:sldIdLst>
         </p14:section>
-        <p14:section name="Werkbeispiele" id="{86d9aea5-427f-02ba-ed4f-93169984ad7e}">
+        <p14:section name="Werkbeispiele" id="{4c19fb95-e77b-d4f8-308a-36bbecd6f576}">
           <p14:sldIdLst>
             <p14:sldId id="268"/>
             <p14:sldId id="269"/>
@@ -167,7 +167,7 @@
             <p14:sldId id="272"/>
           </p14:sldIdLst>
         </p14:section>
-        <p14:section name="Fazit &amp; Quellen" id="{93ab0b41-5cd7-99fc-6cc9-348f0ab5dc37}">
+        <p14:section name="Fazit &amp; Quellen" id="{ab6b5560-02b8-44cc-3ca6-a0c380b37df1}">
           <p14:sldIdLst>
             <p14:sldId id="273"/>
             <p14:sldId id="274"/>
@@ -842,7 +842,7 @@
           <a:p>
             <a:r>
               <a:rPr lang="en-US" dirty="0"/>
-              <a:t>Im Hyperrealismus spielen Skulpturen eine große Rolle. Duane Hanson schuf lebensgroße Figuren von Alltagsmenschen, mit echter Kleidung. John De Andrea arbeitet ähnlich, zeigt aber nackte Figuren. Ron Mueck spielt mit dem Maßstab: Seine Figuren sind riesig oder winzig, aber bis zur Pore detailliert. In der Malerei sind zum Beispiel Gottfried Helnwein, Roberto Bernardi und Alyssa Monks wichtig. (ca. 45 Sekunden)</a:t>
+              <a:t>Im Hyperrealismus spielen Skulpturen eine große Rolle. Duane Hanson schuf lebensgroße Figuren von Alltagsmenschen, mit echter Kleidung. John De Andrea arbeitet ähnlich, zeigt aber nackte Figuren. Ron Mueck spielt mit dem Maßstab: Seine Figuren sind riesig oder winzig, aber bis zur Pore detailliert. In der Malerei sind zum Beispiel Gottfried Helnwein, Roberto Bernardi und Robin Eley wichtig – bei Eley sieht man Menschen in Plastikfolie, aber die Folie ist nur gemalt. (ca. 45 Sekunden)</a:t>
             </a:r>
             <a:endParaRPr lang="en-US" dirty="0"/>
           </a:p>
@@ -930,7 +930,7 @@
           <a:p>
             <a:r>
               <a:rPr lang="en-US" dirty="0"/>
-              <a:t>Links: Malcolm Morley, „SS Amsterdam in Front of Rotterdam“, 1966. Morley malte nach einer Postkarte und übertrug sie mit einem Raster – sogar der weiße Rand der Postkarte ist mitgemalt. Rechts: Franz Gertsch, „Medici“, 1971. Das riesige Bild zeigt eine Gruppe junger Leute und wurde auf der documenta 5 gezeigt. (ca. 40 Sekunden)</a:t>
+              <a:t>Links: Malcolm Morley: SS Amsterdam in Front of Rotterdam, 1966. Morley malte das Schiff nach einem gedruckten Werbebild der Reederei und übertrug es mit einem Raster Feld für Feld – sogar der weiße Rand der Vorlage ist mitgemalt. Morley nannte seine Malweise „Superrealism“. Rechts: Franz Gertsch: Medici, 1971/72. Fünf junge Männer lehnen an einer Bauabsperrung der Firma „Medici“ – daher der Titel. Das Bild ist vier mal sechs Meter groß, entstand nach einem einzigen Schnappschuss und brachte Gertsch 1972 auf der documenta 5 den Durchbruch. (ca. 45 Sekunden)</a:t>
             </a:r>
             <a:endParaRPr lang="en-US" dirty="0"/>
           </a:p>
@@ -1018,7 +1018,7 @@
           <a:p>
             <a:r>
               <a:rPr lang="en-US" dirty="0"/>
-              <a:t>Links: Robert Bechtle, „'61 Pontiac“, 1968–69. Eine Familie steht vor ihrem Auto – das Bild wirkt wie ein ganz normales Familienfoto. Rechts: Don Eddy, „New Shoes for H“, 1973–74. Man blickt in ein Schuhgeschäft; Spiegelungen und Durchblick überlagern sich, sodass man kaum sagen kann, was vor und was hinter der Scheibe ist. (ca. 40 Sekunden)</a:t>
+              <a:t>Links: Robert Bechtle: ’61 Pontiac, 1968–69. Der Künstler steht mit seiner Familie vor ihrem Pontiac-Kombi – Vorlage war ein ganz normales Familienfoto. Das Bild hing 1972 auf der documenta 5. Rechts: Don Eddy: New Shoes for H, 1973–74. Man blickt in ein Schuhgeschäft; Spiegelungen der Straße legen sich über die Schuhe, sodass man kaum sagen kann, was vor und was hinter der Scheibe ist. (ca. 40 Sekunden)</a:t>
             </a:r>
             <a:endParaRPr lang="en-US" dirty="0"/>
           </a:p>
@@ -1106,7 +1106,7 @@
           <a:p>
             <a:r>
               <a:rPr lang="en-US" dirty="0"/>
-              <a:t>Links: Audrey Flack, „Marilyn (Vanitas)“, 1977. Ein Vanitas-Stillleben über Marilyn Monroe: Schminke, Obst, Uhr und Kerze stehen für Schönheit und Vergänglichkeit. Rechts: Charles Bell, „Gumball No. 10: Sugar Daddy“, 1975. Ein Kaugummiautomat wird riesig vergrößert – ein einfaches Konsumgut wird zum Kunstwerk. (ca. 40 Sekunden)</a:t>
+              <a:t>Links: Audrey Flack: Marilyn (Vanitas), 1977. Ein Vanitas-Stillleben rund um ein Foto der jungen Marilyn Monroe: Sanduhr, Kerze, Obst und Schminke stehen für Schönheit und Vergänglichkeit. Flack hat die Dinge arrangiert, fotografiert und das Dia direkt auf die Leinwand projiziert. Rechts: Charles Bell: Gum Ball No. 10: „Sugar Daddy“, 1975. Ein Kaugummiautomat, vergrößert auf 1,68 Meter – ein billiges Konsumprodukt wird zum monumentalen Bild, und Bell zeigt, wie Licht in Glas gespiegelt und gebrochen wird. (ca. 45 Sekunden)</a:t>
             </a:r>
             <a:endParaRPr lang="en-US" dirty="0"/>
           </a:p>
@@ -1194,7 +1194,7 @@
           <a:p>
             <a:r>
               <a:rPr lang="en-US" dirty="0"/>
-              <a:t>Links: Duane Hanson, „Supermarket Lady“, 1969. Eine Frau mit vollem Einkaufswagen – im Museum halten Besucher sie oft für eine echte Person. Rechts: Ron Mueck, „Boy“, 1999. Ein riesig vergrößerter, kauernder Junge. Durch den veränderten Maßstab sehen wir jede Pore – und fühlen uns gleichzeitig unwohl. (ca. 40 Sekunden)</a:t>
+              <a:t>Links: Duane Hanson: Supermarket Lady, 1969/70. Eine Hausfrau mit Lockenwicklern schiebt einen Einkaufswagen voller echter Lebensmittelverpackungen. Hanson hat die Figur über einem lebenden Menschen abgegossen und naturgetreu bemalt; die Kleidung ist echt. Im Museum halten Besucher sie oft für eine echte Person. Man versteht sie auch als Kritik an der Konsumgesellschaft. Rechts: Ron Mueck: Mask II, 2001–02. Ein riesiger Kopf – ein Selbstporträt von Mueck – liegt wie schlafend auf der Seite. Jede Pore und jede Bartstoppel ist zu sehen. Von hinten ist der Kopf hohl wie eine Maske: Die Illusion wird bewusst gebrochen. (ca. 50 Sekunden)</a:t>
             </a:r>
             <a:endParaRPr lang="en-US" dirty="0"/>
           </a:p>
@@ -1282,7 +1282,7 @@
           <a:p>
             <a:r>
               <a:rPr lang="en-US" dirty="0"/>
-              <a:t>Links: Gottfried Helnwein, „Epiphany I (Adoration of the Magi)“, 1996. Helnwein nutzt die hyperrealistische Malweise, um zu provozieren und zum Nachdenken anzuregen. Rechts: Roberto Bernardi, „Tutti Frutti“, 2008. Glas, Farben und Spiegelungen sind so präzise, dass das Bild schärfer wirkt als jedes Foto. (ca. 40 Sekunden)</a:t>
+              <a:t>Links: Gottfried Helnwein: Epiphany II (Adoration of the Shepherds), 1998. Aus Helnweins Serie „Epiphany“: Er verbindet ein christliches Bildthema mit Figuren in Uniformen der NS-Zeit. Das Bild wirkt wie ein riesiges historisches Foto und will provozieren – Hyperrealismus wird hier zum Mittel der Gesellschaftskritik. Rechts: Gregory Thielker: Exhale, 2023. Wir blicken durch eine verregnete Windschutzscheibe. Die Tropfen sind gestochen scharf, die Landschaft dahinter verschwimmt – Thielker malt also, wie eine Kameralinse sieht. Der Hyperrealismus ist bis heute lebendig. (ca. 45 Sekunden)</a:t>
             </a:r>
             <a:endParaRPr lang="en-US" dirty="0"/>
           </a:p>
@@ -1458,7 +1458,7 @@
           <a:p>
             <a:r>
               <a:rPr lang="en-US" dirty="0"/>
-              <a:t>Quellenangaben – nicht vortragen, nur zeigen.</a:t>
+              <a:t>Quellenangaben – nicht vortragen, nur kurz zeigen.</a:t>
             </a:r>
             <a:endParaRPr lang="en-US" dirty="0"/>
           </a:p>
@@ -1546,7 +1546,7 @@
           <a:p>
             <a:r>
               <a:rPr lang="en-US" dirty="0"/>
-              <a:t>Kurz ins Publikum fragen: Ist das ein Foto oder ein Gemälde? – Auflösung: Es ist ein Gemälde! Ralph Goings, „Ralph's Diner“, 1981–82. Jedes Detail – das Chrom, die Spiegelungen, die Ketchupflasche – ist von Hand gemalt. Genau diese Verwechslungsgefahr ist das Thema des Fotorealismus. (ca. 40 Sekunden)</a:t>
+              <a:t>Kurz ins Publikum fragen: Ist das ein Foto oder ein Gemälde? – Auflösung: Es ist ein Gemälde, über zwei Meter breit! Ralph Goings: Airstream, 1970. Jede Spiegelung auf dem glänzenden Aluminium und jeder Schatten ist von Hand gemalt, nach einem Foto. Genau diese Verwechslungsgefahr ist das Thema des Fotorealismus. (ca. 40 Sekunden)</a:t>
             </a:r>
             <a:endParaRPr lang="en-US" dirty="0"/>
           </a:p>
@@ -1634,7 +1634,7 @@
           <a:p>
             <a:r>
               <a:rPr lang="en-US" dirty="0"/>
-              <a:t>Bildnachweise – nicht vortragen, nur zeigen.</a:t>
+              <a:t>Bildnachweise – nicht vortragen, nur kurz zeigen.</a:t>
             </a:r>
             <a:endParaRPr lang="en-US" dirty="0"/>
           </a:p>
@@ -1810,7 +1810,7 @@
           <a:p>
             <a:r>
               <a:rPr lang="en-US" dirty="0"/>
-              <a:t>Der Fotorealismus entsteht Ende der 1960er-Jahre in den USA, vor allem in Kalifornien und New York. Vorher hat die Pop Art schon Werbung und Alltagsbilder in die Kunst geholt – daran knüpfen die Fotorealisten an, wenden sich aber gegen die damals vorherrschende abstrakte Malerei. 1966 malt Malcolm Morley ein Kreuzfahrtschiff nach einer Postkarte – das gilt als eines der ersten Werke dieser Art. 1969 prägt der New Yorker Galerist Louis K. Meisel den Begriff „Photo-Realism“. Den Durchbruch in Europa bringt 1972 die documenta 5 in Kassel. 1973 taucht in Brüssel der Begriff „Hyperrealismus“ auf. 1980 legt Meisel in seinem Buch fünf Kriterien fest. Seit etwa 2000 erlebt der Hyperrealismus einen Boom – durch digitale Fotografie und neue Materialien wie Silikon. (ca. 70 Sekunden)</a:t>
+              <a:t>Der Fotorealismus entsteht Ende der 1960er-Jahre in den USA, vor allem in New York und Kalifornien. Er ist eine Gegenbewegung zum Abstrakten Expressionismus, bei dem man jeden Pinselschwung sieht. Von der Pop Art übernehmen die Fotorealisten den Blick auf Werbung, Konsum und Alltag. 1966 malt Malcolm Morley ein Kreuzfahrtschiff nach einer Postkarte – das gilt als eines der ersten Werke dieser Art. 1969 prägt der New Yorker Galerist Louis K. Meisel den Begriff „Photo-Realism“, 1970 steht er zum ersten Mal gedruckt, im Katalog einer Ausstellung im Whitney Museum. 1972 zeigt die documenta 5 in Kassel viele Fotorealisten – ihr erster großer Auftritt in Europa. 1973 kommt in Brüssel der Begriff „Hyperrealismus“ auf. 1980 erscheint Meisels Standardwerk über die erste Generation. Seit etwa 2000 erlebt der Hyperrealismus einen Boom – durch digitale Fotografie und neue Materialien wie Silikon. (ca. 75 Sekunden)</a:t>
             </a:r>
             <a:endParaRPr lang="en-US" dirty="0"/>
           </a:p>
@@ -2074,7 +2074,7 @@
           <a:p>
             <a:r>
               <a:rPr lang="en-US" dirty="0"/>
-              <a:t>Das erste Bildbeispiel: Richard Estes, „Telephone Booths“, 1967. Man sieht eine Reihe von Telefonzellen in New York. Auffällig sind die Spiegelungen im Glas und im Metall – Spiegelungen sind das Markenzeichen von Estes. Außerdem ist alles gleich scharf, vom Vordergrund bis zum Hintergrund, und man sieht keinen einzigen Pinselstrich. Das Motiv ist völlig alltäglich und wird ohne Wertung gezeigt. Estes malt nach eigenen Fotos und setzt oft mehrere Aufnahmen zu einem Bild zusammen. (ca. 50 Sekunden)</a:t>
+              <a:t>Das erste Bildbeispiel: Richard Estes: Telephone Booths, 1967. Man sieht eine Reihe von Telefonzellen in New York. Auffällig sind die Spiegelungen im Glas und im Metall – Spiegelungen sind das Markenzeichen von Estes. Außerdem ist alles gleich scharf, vom Vordergrund bis zum Hintergrund – das schafft weder unser Auge noch eine Kamera auf einmal. Möglich wird das, weil Estes ohne Projektor arbeitet und mehrere eigene Fotos zu einem Bild zusammensetzt. Man sieht keinen einzigen Pinselstrich, und das Motiv ist völlig alltäglich und wird ohne Wertung gezeigt. Das Bild ist also schärfer als die Wirklichkeit. (ca. 55 Sekunden)</a:t>
             </a:r>
             <a:endParaRPr lang="en-US" dirty="0"/>
           </a:p>
@@ -2162,7 +2162,7 @@
           <a:p>
             <a:r>
               <a:rPr lang="en-US" dirty="0"/>
-              <a:t>Das zweite Bildbeispiel: Chuck Close, „Big Self-Portrait“, 1967–68. Das Bild ist 2,73 Meter hoch – das Gesicht wirkt dadurch monumental. Close hat ein Foto von sich in ein Raster aus Quadraten geteilt und es Feld für Feld auf die Leinwand übertragen. Interessant ist: Close übernimmt sogar die Unschärfe der Kamera. Das Gesicht ist scharf, Haare und Schultern verschwimmen. Gemalt hat er mit Airbrush in Schwarz-Weiß. Und das Porträt ist nicht geschönt: Zigarette im Mund, zerzauste Haare – wie ein zufälliger Schnappschuss. (ca. 50 Sekunden)</a:t>
+              <a:t>Das zweite Bildbeispiel: Chuck Close: Big Self-Portrait, 1967–68. Das Bild ist 2,73 Meter hoch – das Gesicht wirkt dadurch monumental. Close hat über ein Foto von sich ein Raster aus Quadraten gelegt und es Feld für Feld auf die Leinwand übertragen, mit der Spritzpistole, also Airbrush, in Schwarz-Weiß. Interessant ist: Close übernimmt sogar die Unschärfe der Kamera. Die Augen sind scharf, Nasenspitze und Ohren verschwimmen – so, wie es eine Kamera bei geringer Tiefenschärfe aufnimmt. Und das Porträt ist nicht geschönt: Zigarette im Mund, zerzauste Haare, Bartstoppeln. Übrigens war es das erste Bild, das Close verkauft hat – 1969 an das Walker Art Center. (ca. 55 Sekunden)</a:t>
             </a:r>
             <a:endParaRPr lang="en-US" dirty="0"/>
           </a:p>
@@ -2250,7 +2250,7 @@
           <a:p>
             <a:r>
               <a:rPr lang="en-US" dirty="0"/>
-              <a:t>So entsteht ein fotorealistisches Bild: Zuerst wird fotografiert, oft werden mehrere Fotos kombiniert. Dann wird das Bild übertragen – mit einem Raster oder indem man ein Dia direkt auf die Leinwand projiziert und nachzeichnet. Danach wird Schicht für Schicht gemalt, oft mit Airbrush. An einem Bild arbeiten die Künstler häufig mehrere Monate. Der Galerist Louis K. Meisel hat 1980 fünf Kriterien formuliert: Fotorealisten arbeiten mit Kamera und Foto, übertragen mechanisch, haben das Können für eine fotografische Wirkung – und die beiden letzten Kriterien grenzen die Kerngruppe zeitlich ein. (ca. 60 Sekunden)</a:t>
+              <a:t>So entsteht ein fotorealistisches Bild: Zuerst wird fotografiert, oft werden mehrere Fotos kombiniert. Dann wird das Bild übertragen – mit einem Raster oder indem man ein Dia direkt auf die Leinwand projiziert und nachzeichnet. Danach wird Schicht für Schicht gemalt, oft mit Airbrush. An einem Bild arbeiten die Künstler häufig mehrere Monate. Der Galerist Louis K. Meisel hat 1972 fünf Kriterien formuliert: Fotorealisten arbeiten mit Kamera und Foto, übertragen mechanisch, haben das Können für eine fotografische Wirkung – und die beiden letzten Kriterien grenzen die Kerngruppe zeitlich ein. Kritiker meinten übrigens, Meisel habe die Kriterien so gewählt, dass vor allem seine eigenen Künstler hineinpassen. (ca. 65 Sekunden)</a:t>
             </a:r>
             <a:endParaRPr lang="en-US" dirty="0"/>
           </a:p>
@@ -3768,7 +3768,7 @@
                 <a:ea typeface="Arial" pitchFamily="34" charset="-122"/>
                 <a:cs typeface="Arial" pitchFamily="34" charset="-120"/>
               </a:rPr>
-              <a:t>Spiegelungen in Glas, Chrom und Lack</a:t>
+              <a:t>Spiegelungen, Reklame, Leuchtschrift</a:t>
             </a:r>
             <a:endParaRPr lang="en-US" sz="1500" dirty="0"/>
           </a:p>
@@ -3788,7 +3788,7 @@
                 <a:ea typeface="Arial" pitchFamily="34" charset="-122"/>
                 <a:cs typeface="Arial" pitchFamily="34" charset="-120"/>
               </a:rPr>
-              <a:t>Richard Estes, Don Eddy</a:t>
+              <a:t>Richard Estes, Don Eddy, Robert Cottingham</a:t>
             </a:r>
             <a:endParaRPr lang="en-US" sz="1500" dirty="0"/>
           </a:p>
@@ -3901,7 +3901,7 @@
                 <a:ea typeface="Arial" pitchFamily="34" charset="-122"/>
                 <a:cs typeface="Arial" pitchFamily="34" charset="-120"/>
               </a:rPr>
-              <a:t>Autos &amp; Motorräder</a:t>
+              <a:t>Autos &amp; Wohnwagen</a:t>
             </a:r>
             <a:endParaRPr lang="en-US" sz="1700" dirty="0"/>
           </a:p>
@@ -3943,7 +3943,7 @@
                 <a:ea typeface="Arial" pitchFamily="34" charset="-122"/>
                 <a:cs typeface="Arial" pitchFamily="34" charset="-120"/>
               </a:rPr>
-              <a:t>Symbole des „American Way of Life“</a:t>
+              <a:t>Chrom und Lack – Symbole des „American Way of Life“</a:t>
             </a:r>
             <a:endParaRPr lang="en-US" sz="1500" dirty="0"/>
           </a:p>
@@ -3963,7 +3963,7 @@
                 <a:ea typeface="Arial" pitchFamily="34" charset="-122"/>
                 <a:cs typeface="Arial" pitchFamily="34" charset="-120"/>
               </a:rPr>
-              <a:t>Robert Bechtle, Tom Blackwell</a:t>
+              <a:t>Robert Bechtle, Ralph Goings, Tom Blackwell</a:t>
             </a:r>
             <a:endParaRPr lang="en-US" sz="1500" dirty="0"/>
           </a:p>
@@ -4960,7 +4960,7 @@
                 <a:ea typeface="Arial" pitchFamily="34" charset="-122"/>
                 <a:cs typeface="Arial" pitchFamily="34" charset="-120"/>
               </a:rPr>
-              <a:t>Stadtansichten New Yorks mit Spiegelungen in Glas und Chrom</a:t>
+              <a:t>Mitbegründer; New Yorker Stadtansichten voller Spiegelungen</a:t>
             </a:r>
             <a:endParaRPr lang="en-US" sz="1600" dirty="0"/>
           </a:p>
@@ -5386,7 +5386,7 @@
                 <a:ea typeface="Arial" pitchFamily="34" charset="-122"/>
                 <a:cs typeface="Arial" pitchFamily="34" charset="-120"/>
               </a:rPr>
-              <a:t>Pionierin des Fotorealismus; Vanitas-Stillleben mit Airbrush</a:t>
+              <a:t>Wichtigste Künstlerin der ersten Generation; Vanitas-Stillleben</a:t>
             </a:r>
             <a:endParaRPr lang="en-US" sz="1600" dirty="0"/>
           </a:p>
@@ -5670,7 +5670,7 @@
                 <a:ea typeface="Arial" pitchFamily="34" charset="-122"/>
                 <a:cs typeface="Arial" pitchFamily="34" charset="-120"/>
               </a:rPr>
-              <a:t>Bedeutendster europäischer Fotorealist; riesige Porträts</a:t>
+              <a:t>Wichtigster europäischer Fotorealist; Durchbruch auf der documenta 5</a:t>
             </a:r>
             <a:endParaRPr lang="en-US" sz="1600" dirty="0"/>
           </a:p>
@@ -6212,7 +6212,7 @@
                 <a:ea typeface="Arial" pitchFamily="34" charset="-122"/>
                 <a:cs typeface="Arial" pitchFamily="34" charset="-120"/>
               </a:rPr>
-              <a:t>* 1958 · Australien</a:t>
+              <a:t>* 1958 · Australien, lebt in London</a:t>
             </a:r>
             <a:endParaRPr lang="en-US" sz="1300" dirty="0"/>
           </a:p>
@@ -6599,7 +6599,7 @@
                 <a:ea typeface="Georgia" pitchFamily="34" charset="-122"/>
                 <a:cs typeface="Georgia" pitchFamily="34" charset="-120"/>
               </a:rPr>
-              <a:t>Alyssa Monks</a:t>
+              <a:t>Robin Eley</a:t>
             </a:r>
             <a:endParaRPr lang="en-US" sz="2000" dirty="0"/>
           </a:p>
@@ -6638,7 +6638,7 @@
                 <a:ea typeface="Arial" pitchFamily="34" charset="-122"/>
                 <a:cs typeface="Arial" pitchFamily="34" charset="-120"/>
               </a:rPr>
-              <a:t>* 1977 · USA</a:t>
+              <a:t>* 1978 · Großbritannien/Australien</a:t>
             </a:r>
             <a:endParaRPr lang="en-US" sz="1300" dirty="0"/>
           </a:p>
@@ -6677,7 +6677,7 @@
                 <a:ea typeface="Arial" pitchFamily="34" charset="-122"/>
                 <a:cs typeface="Arial" pitchFamily="34" charset="-120"/>
               </a:rPr>
-              <a:t>Körper hinter Wasser und beschlagenem Glas</a:t>
+              <a:t>Menschen in Plastikfolie – die Folie ist nur gemalt</a:t>
             </a:r>
             <a:endParaRPr lang="en-US" sz="1600" dirty="0"/>
           </a:p>
@@ -6847,7 +6847,7 @@
         <p:spPr>
           <a:xfrm>
             <a:off x="640080" y="1783080"/>
-            <a:ext cx="4404985" cy="3246120"/>
+            <a:ext cx="4414723" cy="3246120"/>
           </a:xfrm>
           <a:prstGeom prst="rect">
             <a:avLst/>
@@ -6879,7 +6879,7 @@
         </p:blipFill>
         <p:spPr>
           <a:xfrm>
-            <a:off x="2591112" y="2857500"/>
+            <a:off x="2595982" y="2857500"/>
             <a:ext cx="502920" cy="502920"/>
           </a:xfrm>
           <a:prstGeom prst="rect">
@@ -6896,7 +6896,7 @@
         <p:spPr>
           <a:xfrm>
             <a:off x="777240" y="3424428"/>
-            <a:ext cx="4130665" cy="731520"/>
+            <a:ext cx="4140403" cy="731520"/>
           </a:xfrm>
           <a:prstGeom prst="rect">
             <a:avLst/>
@@ -6999,7 +6999,7 @@
         </p:nvSpPr>
         <p:spPr>
           <a:xfrm>
-            <a:off x="4898761" y="1691640"/>
+            <a:off x="4908499" y="1691640"/>
             <a:ext cx="237744" cy="0"/>
           </a:xfrm>
           <a:prstGeom prst="line">
@@ -7022,7 +7022,7 @@
         </p:nvSpPr>
         <p:spPr>
           <a:xfrm>
-            <a:off x="5136505" y="1691640"/>
+            <a:off x="5146243" y="1691640"/>
             <a:ext cx="0" cy="237744"/>
           </a:xfrm>
           <a:prstGeom prst="line">
@@ -7091,7 +7091,7 @@
         </p:nvSpPr>
         <p:spPr>
           <a:xfrm>
-            <a:off x="4898761" y="5120640"/>
+            <a:off x="4908499" y="5120640"/>
             <a:ext cx="237744" cy="0"/>
           </a:xfrm>
           <a:prstGeom prst="line">
@@ -7114,7 +7114,7 @@
         </p:nvSpPr>
         <p:spPr>
           <a:xfrm>
-            <a:off x="5136505" y="4882896"/>
+            <a:off x="5146243" y="4882896"/>
             <a:ext cx="0" cy="237744"/>
           </a:xfrm>
           <a:prstGeom prst="line">
@@ -7199,7 +7199,7 @@
                 <a:ea typeface="Arial" pitchFamily="34" charset="-122"/>
                 <a:cs typeface="Arial" pitchFamily="34" charset="-120"/>
               </a:rPr>
-              <a:t> (Die SS Amsterdam vor Rotterdam), 1966</a:t>
+              <a:t> (Die „SS Amsterdam“ vor Rotterdam), 1966</a:t>
             </a:r>
             <a:endParaRPr lang="en-US" sz="1300" dirty="0"/>
           </a:p>
@@ -7219,7 +7219,7 @@
                 <a:ea typeface="Arial" pitchFamily="34" charset="-122"/>
                 <a:cs typeface="Arial" pitchFamily="34" charset="-120"/>
               </a:rPr>
-              <a:t>Acryl auf Leinwand, 157 × 213 cm · Privatsammlung</a:t>
+              <a:t>Acryl auf Leinwand, ca. 158 × 214 cm · Privatsammlung</a:t>
             </a:r>
             <a:endParaRPr lang="en-US" sz="1300" dirty="0"/>
           </a:p>
@@ -7239,7 +7239,7 @@
                 <a:ea typeface="Arial" pitchFamily="34" charset="-122"/>
                 <a:cs typeface="Arial" pitchFamily="34" charset="-120"/>
               </a:rPr>
-              <a:t>→ Postkarte als Vorlage – Raster für Raster übertragen</a:t>
+              <a:t>→ Werbebild als Vorlage – per Raster Feld für Feld übertragen</a:t>
             </a:r>
             <a:endParaRPr lang="en-US" sz="1300" dirty="0"/>
           </a:p>
@@ -7606,7 +7606,7 @@
                 <a:ea typeface="Arial" pitchFamily="34" charset="-122"/>
                 <a:cs typeface="Arial" pitchFamily="34" charset="-120"/>
               </a:rPr>
-              <a:t>, 1971</a:t>
+              <a:t>, 1971/72</a:t>
             </a:r>
             <a:endParaRPr lang="en-US" sz="1300" dirty="0"/>
           </a:p>
@@ -7626,7 +7626,7 @@
                 <a:ea typeface="Arial" pitchFamily="34" charset="-122"/>
                 <a:cs typeface="Arial" pitchFamily="34" charset="-120"/>
               </a:rPr>
-              <a:t>Dispersion auf ungrundierter Baumwolle, 400 × 600 cm · Ludwig Forum für Internationale Kunst, Aachen</a:t>
+              <a:t>Dispersion auf ungrundiertem Halbleinen, 400 × 600 cm · Ludwig Forum für Internationale Kunst, Aachen</a:t>
             </a:r>
             <a:endParaRPr lang="en-US" sz="1300" dirty="0"/>
           </a:p>
@@ -7646,7 +7646,7 @@
                 <a:ea typeface="Arial" pitchFamily="34" charset="-122"/>
                 <a:cs typeface="Arial" pitchFamily="34" charset="-120"/>
               </a:rPr>
-              <a:t>→ Riesenformat, gezeigt auf der documenta 5 (1972)</a:t>
+              <a:t>→ 4 × 6 m nach einem Schnappschuss – Durchbruch auf der documenta 5</a:t>
             </a:r>
             <a:endParaRPr lang="en-US" sz="1300" dirty="0"/>
           </a:p>
@@ -7816,7 +7816,7 @@
         <p:spPr>
           <a:xfrm>
             <a:off x="640080" y="1783080"/>
-            <a:ext cx="4544568" cy="3246120"/>
+            <a:ext cx="4577029" cy="3246120"/>
           </a:xfrm>
           <a:prstGeom prst="rect">
             <a:avLst/>
@@ -7848,7 +7848,7 @@
         </p:blipFill>
         <p:spPr>
           <a:xfrm>
-            <a:off x="2660904" y="2857500"/>
+            <a:off x="2677135" y="2857500"/>
             <a:ext cx="502920" cy="502920"/>
           </a:xfrm>
           <a:prstGeom prst="rect">
@@ -7865,7 +7865,7 @@
         <p:spPr>
           <a:xfrm>
             <a:off x="777240" y="3424428"/>
-            <a:ext cx="4270248" cy="731520"/>
+            <a:ext cx="4302709" cy="731520"/>
           </a:xfrm>
           <a:prstGeom prst="rect">
             <a:avLst/>
@@ -7908,7 +7908,7 @@
                 <a:ea typeface="Arial" pitchFamily="34" charset="-122"/>
                 <a:cs typeface="Arial" pitchFamily="34" charset="-120"/>
               </a:rPr>
-              <a:t>Robert Bechtle: '61 Pontiac</a:t>
+              <a:t>Robert Bechtle: ’61 Pontiac</a:t>
             </a:r>
             <a:endParaRPr lang="en-US" sz="1100" dirty="0"/>
           </a:p>
@@ -7968,7 +7968,7 @@
         </p:nvSpPr>
         <p:spPr>
           <a:xfrm>
-            <a:off x="5038344" y="1691640"/>
+            <a:off x="5070805" y="1691640"/>
             <a:ext cx="237744" cy="0"/>
           </a:xfrm>
           <a:prstGeom prst="line">
@@ -7991,7 +7991,7 @@
         </p:nvSpPr>
         <p:spPr>
           <a:xfrm>
-            <a:off x="5276088" y="1691640"/>
+            <a:off x="5308549" y="1691640"/>
             <a:ext cx="0" cy="237744"/>
           </a:xfrm>
           <a:prstGeom prst="line">
@@ -8060,7 +8060,7 @@
         </p:nvSpPr>
         <p:spPr>
           <a:xfrm>
-            <a:off x="5038344" y="5120640"/>
+            <a:off x="5070805" y="5120640"/>
             <a:ext cx="237744" cy="0"/>
           </a:xfrm>
           <a:prstGeom prst="line">
@@ -8083,7 +8083,7 @@
         </p:nvSpPr>
         <p:spPr>
           <a:xfrm>
-            <a:off x="5276088" y="4882896"/>
+            <a:off x="5308549" y="4882896"/>
             <a:ext cx="0" cy="237744"/>
           </a:xfrm>
           <a:prstGeom prst="line">
@@ -8151,7 +8151,7 @@
                 <a:ea typeface="Arial" pitchFamily="34" charset="-122"/>
                 <a:cs typeface="Arial" pitchFamily="34" charset="-120"/>
               </a:rPr>
-              <a:t>'61 Pontiac</a:t>
+              <a:t>’61 Pontiac</a:t>
             </a:r>
             <a:pPr indent="0" marL="0">
               <a:spcAft>
@@ -8168,7 +8168,7 @@
                 <a:ea typeface="Arial" pitchFamily="34" charset="-122"/>
                 <a:cs typeface="Arial" pitchFamily="34" charset="-120"/>
               </a:rPr>
-              <a:t> (Pontiac von 1961), 1968–69</a:t>
+              <a:t>, 1968–69</a:t>
             </a:r>
             <a:endParaRPr lang="en-US" sz="1300" dirty="0"/>
           </a:p>
@@ -8188,7 +8188,7 @@
                 <a:ea typeface="Arial" pitchFamily="34" charset="-122"/>
                 <a:cs typeface="Arial" pitchFamily="34" charset="-120"/>
               </a:rPr>
-              <a:t>Öl auf Leinwand, 152,4 × 213,4 cm · Whitney Museum of American Art, New York</a:t>
+              <a:t>Öl auf Leinwand, 151,8 × 214 cm · Whitney Museum of American Art, New York</a:t>
             </a:r>
             <a:endParaRPr lang="en-US" sz="1300" dirty="0"/>
           </a:p>
@@ -8208,7 +8208,7 @@
                 <a:ea typeface="Arial" pitchFamily="34" charset="-122"/>
                 <a:cs typeface="Arial" pitchFamily="34" charset="-120"/>
               </a:rPr>
-              <a:t>→ Familie vor dem Auto – wie ein Schnappschuss</a:t>
+              <a:t>→ Familienschnappschuss als Vorlage – Chrom und Lack glänzen</a:t>
             </a:r>
             <a:endParaRPr lang="en-US" sz="1300" dirty="0"/>
           </a:p>
@@ -8595,7 +8595,7 @@
                 <a:ea typeface="Arial" pitchFamily="34" charset="-122"/>
                 <a:cs typeface="Arial" pitchFamily="34" charset="-120"/>
               </a:rPr>
-              <a:t>Acryl auf Leinwand, 111,8 × 121,9 cm · Cleveland Museum of Art</a:t>
+              <a:t>Acryl auf Leinwand, 111,7 × 121,9 cm · Cleveland Museum of Art</a:t>
             </a:r>
             <a:endParaRPr lang="en-US" sz="1300" dirty="0"/>
           </a:p>
@@ -9177,7 +9177,7 @@
                 <a:ea typeface="Arial" pitchFamily="34" charset="-122"/>
                 <a:cs typeface="Arial" pitchFamily="34" charset="-120"/>
               </a:rPr>
-              <a:t>→ Vanitas-Stillleben: Schönheit und Vergänglichkeit</a:t>
+              <a:t>→ Vanitas-Stillleben – Dia direkt auf die Leinwand projiziert</a:t>
             </a:r>
             <a:endParaRPr lang="en-US" sz="1300" dirty="0"/>
           </a:p>
@@ -9284,7 +9284,7 @@
                 <a:ea typeface="Arial" pitchFamily="34" charset="-122"/>
                 <a:cs typeface="Arial" pitchFamily="34" charset="-120"/>
               </a:rPr>
-              <a:t>Charles Bell: Gumball No. 10: Sugar Daddy</a:t>
+              <a:t>Charles Bell: Gum Ball No. 10: „Sugar Daddy“</a:t>
             </a:r>
             <a:endParaRPr lang="en-US" sz="1100" dirty="0"/>
           </a:p>
@@ -9527,7 +9527,7 @@
                 <a:ea typeface="Arial" pitchFamily="34" charset="-122"/>
                 <a:cs typeface="Arial" pitchFamily="34" charset="-120"/>
               </a:rPr>
-              <a:t>Gumball No. 10: Sugar Daddy</a:t>
+              <a:t>Gum Ball No. 10: „Sugar Daddy“</a:t>
             </a:r>
             <a:pPr indent="0" marL="0">
               <a:spcAft>
@@ -9564,7 +9564,7 @@
                 <a:ea typeface="Arial" pitchFamily="34" charset="-122"/>
                 <a:cs typeface="Arial" pitchFamily="34" charset="-120"/>
               </a:rPr>
-              <a:t>Öl auf Leinwand, 167,6 × 167,6 cm · Privatsammlung</a:t>
+              <a:t>Öl auf Leinwand, 167,6 × 167,6 cm · Solomon R. Guggenheim Museum, New York</a:t>
             </a:r>
             <a:endParaRPr lang="en-US" sz="1300" dirty="0"/>
           </a:p>
@@ -9584,7 +9584,7 @@
                 <a:ea typeface="Arial" pitchFamily="34" charset="-122"/>
                 <a:cs typeface="Arial" pitchFamily="34" charset="-120"/>
               </a:rPr>
-              <a:t>→ Konsumgut als Großformat – Glas, Glanz, Farbe</a:t>
+              <a:t>→ Kaugummiautomat auf 1,68 m vergrößert – Licht in Glas</a:t>
             </a:r>
             <a:endParaRPr lang="en-US" sz="1300" dirty="0"/>
           </a:p>
@@ -10106,7 +10106,7 @@
                 <a:ea typeface="Arial" pitchFamily="34" charset="-122"/>
                 <a:cs typeface="Arial" pitchFamily="34" charset="-120"/>
               </a:rPr>
-              <a:t> (Supermarkt-Frau), 1969</a:t>
+              <a:t> (Supermarkt-Kundin), 1969/70</a:t>
             </a:r>
             <a:endParaRPr lang="en-US" sz="1300" dirty="0"/>
           </a:p>
@@ -10126,7 +10126,7 @@
                 <a:ea typeface="Arial" pitchFamily="34" charset="-122"/>
                 <a:cs typeface="Arial" pitchFamily="34" charset="-120"/>
               </a:rPr>
-              <a:t>Polyester, Glasfaser, Kleidung, Einkaufswagen, lebensgroß · Ludwig Forum für Internationale Kunst, Aachen</a:t>
+              <a:t>Polyesterharz und Glasfaser, bemalt; echte Kleidung und Waren, lebensgroß · Ludwig Forum für Internationale Kunst, Aachen</a:t>
             </a:r>
             <a:endParaRPr lang="en-US" sz="1300" dirty="0"/>
           </a:p>
@@ -10146,7 +10146,7 @@
                 <a:ea typeface="Arial" pitchFamily="34" charset="-122"/>
                 <a:cs typeface="Arial" pitchFamily="34" charset="-120"/>
               </a:rPr>
-              <a:t>→ Lebensechte Skulptur aus dem Alltag</a:t>
+              <a:t>→ Abguss vom lebenden Modell – echte Kleidung, echte Waren</a:t>
             </a:r>
             <a:endParaRPr lang="en-US" sz="1300" dirty="0"/>
           </a:p>
@@ -10154,14 +10154,14 @@
       </p:sp>
       <p:sp>
         <p:nvSpPr>
-          <p:cNvPr id="16" name="Bildplatzhalter mueck_boy"/>
+          <p:cNvPr id="16" name="Bildplatzhalter mueck_mask"/>
           <p:cNvSpPr/>
           <p:nvPr/>
         </p:nvSpPr>
         <p:spPr>
           <a:xfrm>
             <a:off x="6415888" y="1783080"/>
-            <a:ext cx="2921508" cy="3246120"/>
+            <a:ext cx="4966564" cy="3246120"/>
           </a:xfrm>
           <a:prstGeom prst="rect">
             <a:avLst/>
@@ -10193,7 +10193,7 @@
         </p:blipFill>
         <p:spPr>
           <a:xfrm>
-            <a:off x="7625182" y="2857500"/>
+            <a:off x="8647709" y="2857500"/>
             <a:ext cx="502920" cy="502920"/>
           </a:xfrm>
           <a:prstGeom prst="rect">
@@ -10210,7 +10210,7 @@
         <p:spPr>
           <a:xfrm>
             <a:off x="6553048" y="3424428"/>
-            <a:ext cx="2647188" cy="731520"/>
+            <a:ext cx="4692244" cy="731520"/>
           </a:xfrm>
           <a:prstGeom prst="rect">
             <a:avLst/>
@@ -10253,7 +10253,7 @@
                 <a:ea typeface="Arial" pitchFamily="34" charset="-122"/>
                 <a:cs typeface="Arial" pitchFamily="34" charset="-120"/>
               </a:rPr>
-              <a:t>Ron Mueck: Boy</a:t>
+              <a:t>Ron Mueck: Mask II</a:t>
             </a:r>
             <a:endParaRPr lang="en-US" sz="1100" dirty="0"/>
           </a:p>
@@ -10313,7 +10313,7 @@
         </p:nvSpPr>
         <p:spPr>
           <a:xfrm>
-            <a:off x="9191092" y="1691640"/>
+            <a:off x="11236147" y="1691640"/>
             <a:ext cx="237744" cy="0"/>
           </a:xfrm>
           <a:prstGeom prst="line">
@@ -10336,7 +10336,7 @@
         </p:nvSpPr>
         <p:spPr>
           <a:xfrm>
-            <a:off x="9428836" y="1691640"/>
+            <a:off x="11473891" y="1691640"/>
             <a:ext cx="0" cy="237744"/>
           </a:xfrm>
           <a:prstGeom prst="line">
@@ -10405,7 +10405,7 @@
         </p:nvSpPr>
         <p:spPr>
           <a:xfrm>
-            <a:off x="9191092" y="5120640"/>
+            <a:off x="11236147" y="5120640"/>
             <a:ext cx="237744" cy="0"/>
           </a:xfrm>
           <a:prstGeom prst="line">
@@ -10428,7 +10428,7 @@
         </p:nvSpPr>
         <p:spPr>
           <a:xfrm>
-            <a:off x="9428836" y="4882896"/>
+            <a:off x="11473891" y="4882896"/>
             <a:ext cx="0" cy="237744"/>
           </a:xfrm>
           <a:prstGeom prst="line">
@@ -10496,7 +10496,7 @@
                 <a:ea typeface="Arial" pitchFamily="34" charset="-122"/>
                 <a:cs typeface="Arial" pitchFamily="34" charset="-120"/>
               </a:rPr>
-              <a:t>Boy</a:t>
+              <a:t>Mask II</a:t>
             </a:r>
             <a:pPr indent="0" marL="0">
               <a:spcAft>
@@ -10513,7 +10513,7 @@
                 <a:ea typeface="Arial" pitchFamily="34" charset="-122"/>
                 <a:cs typeface="Arial" pitchFamily="34" charset="-120"/>
               </a:rPr>
-              <a:t> (Junge), 1999</a:t>
+              <a:t> (Maske II), 2001–02</a:t>
             </a:r>
             <a:endParaRPr lang="en-US" sz="1300" dirty="0"/>
           </a:p>
@@ -10533,7 +10533,7 @@
                 <a:ea typeface="Arial" pitchFamily="34" charset="-122"/>
                 <a:cs typeface="Arial" pitchFamily="34" charset="-120"/>
               </a:rPr>
-              <a:t>Glasfaser, Silikon, Harz, 490 × 490 × 240 cm · ARoS Aarhus Kunstmuseum</a:t>
+              <a:t>Mischtechnik (u. a. Polyesterharz, Glasfaser, Kunsthaar), 77,2 × 118,1 × 85,1 cm · San Francisco Museum of Modern Art</a:t>
             </a:r>
             <a:endParaRPr lang="en-US" sz="1300" dirty="0"/>
           </a:p>
@@ -10553,7 +10553,7 @@
                 <a:ea typeface="Arial" pitchFamily="34" charset="-122"/>
                 <a:cs typeface="Arial" pitchFamily="34" charset="-120"/>
               </a:rPr>
-              <a:t>→ Riesig vergrößert – jede Pore sichtbar</a:t>
+              <a:t>→ Kopf in etwa vierfacher Größe – jede Pore sichtbar</a:t>
             </a:r>
             <a:endParaRPr lang="en-US" sz="1300" dirty="0"/>
           </a:p>
@@ -10708,7 +10708,7 @@
                 <a:ea typeface="Georgia" pitchFamily="34" charset="-122"/>
                 <a:cs typeface="Georgia" pitchFamily="34" charset="-120"/>
               </a:rPr>
-              <a:t>Hyperrealismus heute: schärfer als das Foto</a:t>
+              <a:t>Hyperrealismus heute: mehr als ein Foto</a:t>
             </a:r>
             <a:endParaRPr lang="en-US" sz="3200" dirty="0"/>
           </a:p>
@@ -10716,14 +10716,14 @@
       </p:sp>
       <p:sp>
         <p:nvSpPr>
-          <p:cNvPr id="4" name="Bildplatzhalter helnwein_x"/>
+          <p:cNvPr id="4" name="Bildplatzhalter helnwein_epiphany"/>
           <p:cNvSpPr/>
           <p:nvPr/>
         </p:nvSpPr>
         <p:spPr>
           <a:xfrm>
             <a:off x="640080" y="1783080"/>
-            <a:ext cx="5128870" cy="3246120"/>
+            <a:ext cx="4349801" cy="3246120"/>
           </a:xfrm>
           <a:prstGeom prst="rect">
             <a:avLst/>
@@ -10755,7 +10755,7 @@
         </p:blipFill>
         <p:spPr>
           <a:xfrm>
-            <a:off x="2953055" y="2857500"/>
+            <a:off x="2563520" y="2857500"/>
             <a:ext cx="502920" cy="502920"/>
           </a:xfrm>
           <a:prstGeom prst="rect">
@@ -10772,7 +10772,7 @@
         <p:spPr>
           <a:xfrm>
             <a:off x="777240" y="3424428"/>
-            <a:ext cx="4854550" cy="731520"/>
+            <a:ext cx="4075481" cy="731520"/>
           </a:xfrm>
           <a:prstGeom prst="rect">
             <a:avLst/>
@@ -10815,7 +10815,7 @@
                 <a:ea typeface="Arial" pitchFamily="34" charset="-122"/>
                 <a:cs typeface="Arial" pitchFamily="34" charset="-120"/>
               </a:rPr>
-              <a:t>Gottfried Helnwein: Epiphany I (Adoration of the Magi)</a:t>
+              <a:t>Gottfried Helnwein: Epiphany II (Adoration of the Shepherds)</a:t>
             </a:r>
             <a:endParaRPr lang="en-US" sz="1100" dirty="0"/>
           </a:p>
@@ -10875,7 +10875,7 @@
         </p:nvSpPr>
         <p:spPr>
           <a:xfrm>
-            <a:off x="5622646" y="1691640"/>
+            <a:off x="4843577" y="1691640"/>
             <a:ext cx="237744" cy="0"/>
           </a:xfrm>
           <a:prstGeom prst="line">
@@ -10898,7 +10898,7 @@
         </p:nvSpPr>
         <p:spPr>
           <a:xfrm>
-            <a:off x="5860390" y="1691640"/>
+            <a:off x="5081321" y="1691640"/>
             <a:ext cx="0" cy="237744"/>
           </a:xfrm>
           <a:prstGeom prst="line">
@@ -10967,7 +10967,7 @@
         </p:nvSpPr>
         <p:spPr>
           <a:xfrm>
-            <a:off x="5622646" y="5120640"/>
+            <a:off x="4843577" y="5120640"/>
             <a:ext cx="237744" cy="0"/>
           </a:xfrm>
           <a:prstGeom prst="line">
@@ -10990,7 +10990,7 @@
         </p:nvSpPr>
         <p:spPr>
           <a:xfrm>
-            <a:off x="5860390" y="4882896"/>
+            <a:off x="5081321" y="4882896"/>
             <a:ext cx="0" cy="237744"/>
           </a:xfrm>
           <a:prstGeom prst="line">
@@ -11058,7 +11058,7 @@
                 <a:ea typeface="Arial" pitchFamily="34" charset="-122"/>
                 <a:cs typeface="Arial" pitchFamily="34" charset="-120"/>
               </a:rPr>
-              <a:t>Epiphany I (Adoration of the Magi)</a:t>
+              <a:t>Epiphany II (Adoration of the Shepherds)</a:t>
             </a:r>
             <a:pPr indent="0" marL="0">
               <a:spcAft>
@@ -11075,7 +11075,7 @@
                 <a:ea typeface="Arial" pitchFamily="34" charset="-122"/>
                 <a:cs typeface="Arial" pitchFamily="34" charset="-120"/>
               </a:rPr>
-              <a:t> (Epiphanie I (Anbetung der Könige)), 1996</a:t>
+              <a:t> (Epiphanie II (Anbetung der Hirten)), 1998</a:t>
             </a:r>
             <a:endParaRPr lang="en-US" sz="1300" dirty="0"/>
           </a:p>
@@ -11095,7 +11095,7 @@
                 <a:ea typeface="Arial" pitchFamily="34" charset="-122"/>
                 <a:cs typeface="Arial" pitchFamily="34" charset="-120"/>
               </a:rPr>
-              <a:t>Öl und Acryl auf Leinwand, 210 × 333 cm · San Francisco Museum of Modern Art</a:t>
+              <a:t>Öl und Acryl auf Leinwand, 249,6 × 334 cm · de Young Museum, San Francisco</a:t>
             </a:r>
             <a:endParaRPr lang="en-US" sz="1300" dirty="0"/>
           </a:p>
@@ -11115,7 +11115,7 @@
                 <a:ea typeface="Arial" pitchFamily="34" charset="-122"/>
                 <a:cs typeface="Arial" pitchFamily="34" charset="-120"/>
               </a:rPr>
-              <a:t>→ Hyperrealismus als Provokation</a:t>
+              <a:t>→ Christliches Bildthema trifft NS-Bildwelt – Hyperrealismus als Provokation</a:t>
             </a:r>
             <a:endParaRPr lang="en-US" sz="1300" dirty="0"/>
           </a:p>
@@ -11123,7 +11123,7 @@
       </p:sp>
       <p:sp>
         <p:nvSpPr>
-          <p:cNvPr id="16" name="Bildplatzhalter bernardi_x"/>
+          <p:cNvPr id="16" name="Bildplatzhalter thielker_exhale"/>
           <p:cNvSpPr/>
           <p:nvPr/>
         </p:nvSpPr>
@@ -11222,7 +11222,7 @@
                 <a:ea typeface="Arial" pitchFamily="34" charset="-122"/>
                 <a:cs typeface="Arial" pitchFamily="34" charset="-120"/>
               </a:rPr>
-              <a:t>Roberto Bernardi: Tutti Frutti</a:t>
+              <a:t>Gregory Thielker: Exhale</a:t>
             </a:r>
             <a:endParaRPr lang="en-US" sz="1100" dirty="0"/>
           </a:p>
@@ -11448,7 +11448,7 @@
                 <a:ea typeface="Arial" pitchFamily="34" charset="-122"/>
                 <a:cs typeface="Arial" pitchFamily="34" charset="-120"/>
               </a:rPr>
-              <a:t>Roberto Bernardi, </a:t>
+              <a:t>Gregory Thielker, </a:t>
             </a:r>
             <a:pPr indent="0" marL="0">
               <a:spcAft>
@@ -11465,7 +11465,7 @@
                 <a:ea typeface="Arial" pitchFamily="34" charset="-122"/>
                 <a:cs typeface="Arial" pitchFamily="34" charset="-120"/>
               </a:rPr>
-              <a:t>Tutti Frutti</a:t>
+              <a:t>Exhale</a:t>
             </a:r>
             <a:pPr indent="0" marL="0">
               <a:spcAft>
@@ -11482,7 +11482,7 @@
                 <a:ea typeface="Arial" pitchFamily="34" charset="-122"/>
                 <a:cs typeface="Arial" pitchFamily="34" charset="-120"/>
               </a:rPr>
-              <a:t>, 2008</a:t>
+              <a:t> (Ausatmen), 2023</a:t>
             </a:r>
             <a:endParaRPr lang="en-US" sz="1300" dirty="0"/>
           </a:p>
@@ -11502,7 +11502,7 @@
                 <a:ea typeface="Arial" pitchFamily="34" charset="-122"/>
                 <a:cs typeface="Arial" pitchFamily="34" charset="-120"/>
               </a:rPr>
-              <a:t>Öl auf Leinwand, 100 × 150 cm · Privatsammlung</a:t>
+              <a:t>Öl auf Leinen, 101,6 × 152,4 cm · Guy Hepner Gallery, New York</a:t>
             </a:r>
             <a:endParaRPr lang="en-US" sz="1300" dirty="0"/>
           </a:p>
@@ -11522,7 +11522,7 @@
                 <a:ea typeface="Arial" pitchFamily="34" charset="-122"/>
                 <a:cs typeface="Arial" pitchFamily="34" charset="-120"/>
               </a:rPr>
-              <a:t>→ Glas und Süßigkeiten – schärfer als jedes Foto</a:t>
+              <a:t>→ Tropfen gestochen scharf, Landschaft unscharf – wie durch eine Linse</a:t>
             </a:r>
             <a:endParaRPr lang="en-US" sz="1300" dirty="0"/>
           </a:p>
@@ -12373,71 +12373,10 @@
                 <a:ea typeface="Arial" pitchFamily="34" charset="-122"/>
                 <a:cs typeface="Arial" pitchFamily="34" charset="-120"/>
               </a:rPr>
-              <a:t>(wird nach der Recherche ergänzt)</a:t>
+              <a:t>Battcock, Gregory (Hg.): Super Realism. A Critical Anthology. New York: Dutton 1975.</a:t>
             </a:r>
             <a:endParaRPr lang="en-US" sz="1100" dirty="0"/>
           </a:p>
-        </p:txBody>
-      </p:sp>
-      <p:sp>
-        <p:nvSpPr>
-          <p:cNvPr id="6" name="Text 4"/>
-          <p:cNvSpPr txBox="1"/>
-          <p:nvPr/>
-        </p:nvSpPr>
-        <p:spPr>
-          <a:xfrm>
-            <a:off x="6233008" y="1691640"/>
-            <a:ext cx="5410048" cy="365760"/>
-          </a:xfrm>
-          <a:prstGeom prst="rect">
-            <a:avLst/>
-          </a:prstGeom>
-          <a:noFill/>
-          <a:ln/>
-        </p:spPr>
-        <p:txBody>
-          <a:bodyPr wrap="square" lIns="0" tIns="0" rIns="0" bIns="0" rtlCol="0" anchor="ctr"/>
-          <a:lstStyle/>
-          <a:p>
-            <a:pPr indent="0" marL="0">
-              <a:buNone/>
-            </a:pPr>
-            <a:r>
-              <a:rPr lang="en-US" sz="1500" b="1" dirty="0">
-                <a:solidFill>
-                  <a:schemeClr val="accent1"/>
-                </a:solidFill>
-                <a:latin typeface="Arial" pitchFamily="34" charset="0"/>
-                <a:ea typeface="Arial" pitchFamily="34" charset="-122"/>
-                <a:cs typeface="Arial" pitchFamily="34" charset="-120"/>
-              </a:rPr>
-              <a:t>Internet</a:t>
-            </a:r>
-            <a:endParaRPr lang="en-US" sz="1500" dirty="0"/>
-          </a:p>
-        </p:txBody>
-      </p:sp>
-      <p:sp>
-        <p:nvSpPr>
-          <p:cNvPr id="7" name="Text 5"/>
-          <p:cNvSpPr txBox="1"/>
-          <p:nvPr/>
-        </p:nvSpPr>
-        <p:spPr>
-          <a:xfrm>
-            <a:off x="6233008" y="2148840"/>
-            <a:ext cx="5410048" cy="4023360"/>
-          </a:xfrm>
-          <a:prstGeom prst="rect">
-            <a:avLst/>
-          </a:prstGeom>
-          <a:noFill/>
-          <a:ln/>
-        </p:spPr>
-        <p:txBody>
-          <a:bodyPr wrap="square" lIns="0" tIns="0" rIns="0" bIns="0" rtlCol="0" anchor="t"/>
-          <a:lstStyle/>
           <a:p>
             <a:pPr indent="0" marL="0">
               <a:spcAft>
@@ -12454,7 +12393,288 @@
                 <a:ea typeface="Arial" pitchFamily="34" charset="-122"/>
                 <a:cs typeface="Arial" pitchFamily="34" charset="-120"/>
               </a:rPr>
-              <a:t>(wird nach der Recherche ergänzt)</a:t>
+              <a:t>Letze, Otto (Hg.): Fotorealismus. 50 Jahre hyperrealistische Malerei. Ostfildern: Hatje Cantz 2012.</a:t>
+            </a:r>
+            <a:endParaRPr lang="en-US" sz="1100" dirty="0"/>
+          </a:p>
+          <a:p>
+            <a:pPr indent="0" marL="0">
+              <a:spcAft>
+                <a:spcPts val="600"/>
+              </a:spcAft>
+              <a:buNone/>
+            </a:pPr>
+            <a:r>
+              <a:rPr lang="en-US" sz="1100" dirty="0">
+                <a:solidFill>
+                  <a:schemeClr val="bg1"/>
+                </a:solidFill>
+                <a:latin typeface="Arial" pitchFamily="34" charset="0"/>
+                <a:ea typeface="Arial" pitchFamily="34" charset="-122"/>
+                <a:cs typeface="Arial" pitchFamily="34" charset="-120"/>
+              </a:rPr>
+              <a:t>Meisel, Louis K.: Photo-Realism. New York: Abrams 1980.</a:t>
+            </a:r>
+            <a:endParaRPr lang="en-US" sz="1100" dirty="0"/>
+          </a:p>
+          <a:p>
+            <a:pPr indent="0" marL="0">
+              <a:spcAft>
+                <a:spcPts val="600"/>
+              </a:spcAft>
+              <a:buNone/>
+            </a:pPr>
+            <a:r>
+              <a:rPr lang="en-US" sz="1100" dirty="0">
+                <a:solidFill>
+                  <a:schemeClr val="bg1"/>
+                </a:solidFill>
+                <a:latin typeface="Arial" pitchFamily="34" charset="0"/>
+                <a:ea typeface="Arial" pitchFamily="34" charset="-122"/>
+                <a:cs typeface="Arial" pitchFamily="34" charset="-120"/>
+              </a:rPr>
+              <a:t>mumok Wien (Hg.): Hyper Real. Die Passion des Realen in Malerei und Fotografie. Köln: Walther König 2010.</a:t>
+            </a:r>
+            <a:endParaRPr lang="en-US" sz="1100" dirty="0"/>
+          </a:p>
+          <a:p>
+            <a:pPr indent="0" marL="0">
+              <a:spcAft>
+                <a:spcPts val="600"/>
+              </a:spcAft>
+              <a:buNone/>
+            </a:pPr>
+            <a:r>
+              <a:rPr lang="en-US" sz="1100" dirty="0">
+                <a:solidFill>
+                  <a:schemeClr val="bg1"/>
+                </a:solidFill>
+                <a:latin typeface="Arial" pitchFamily="34" charset="0"/>
+                <a:ea typeface="Arial" pitchFamily="34" charset="-122"/>
+                <a:cs typeface="Arial" pitchFamily="34" charset="-120"/>
+              </a:rPr>
+              <a:t>Zamani, Daniel (Hg.): Wettstreit mit der Wirklichkeit. 60 Jahre Fotorealismus. München: Hirmer 2026 (Kat. Museum Frieder Burda).</a:t>
+            </a:r>
+            <a:endParaRPr lang="en-US" sz="1100" dirty="0"/>
+          </a:p>
+        </p:txBody>
+      </p:sp>
+      <p:sp>
+        <p:nvSpPr>
+          <p:cNvPr id="6" name="Text 4"/>
+          <p:cNvSpPr txBox="1"/>
+          <p:nvPr/>
+        </p:nvSpPr>
+        <p:spPr>
+          <a:xfrm>
+            <a:off x="6233008" y="1691640"/>
+            <a:ext cx="5410048" cy="365760"/>
+          </a:xfrm>
+          <a:prstGeom prst="rect">
+            <a:avLst/>
+          </a:prstGeom>
+          <a:noFill/>
+          <a:ln/>
+        </p:spPr>
+        <p:txBody>
+          <a:bodyPr wrap="square" lIns="0" tIns="0" rIns="0" bIns="0" rtlCol="0" anchor="ctr"/>
+          <a:lstStyle/>
+          <a:p>
+            <a:pPr indent="0" marL="0">
+              <a:buNone/>
+            </a:pPr>
+            <a:r>
+              <a:rPr lang="en-US" sz="1500" b="1" dirty="0">
+                <a:solidFill>
+                  <a:schemeClr val="accent1"/>
+                </a:solidFill>
+                <a:latin typeface="Arial" pitchFamily="34" charset="0"/>
+                <a:ea typeface="Arial" pitchFamily="34" charset="-122"/>
+                <a:cs typeface="Arial" pitchFamily="34" charset="-120"/>
+              </a:rPr>
+              <a:t>Internet</a:t>
+            </a:r>
+            <a:endParaRPr lang="en-US" sz="1500" dirty="0"/>
+          </a:p>
+        </p:txBody>
+      </p:sp>
+      <p:sp>
+        <p:nvSpPr>
+          <p:cNvPr id="7" name="Text 5"/>
+          <p:cNvSpPr txBox="1"/>
+          <p:nvPr/>
+        </p:nvSpPr>
+        <p:spPr>
+          <a:xfrm>
+            <a:off x="6233008" y="2148840"/>
+            <a:ext cx="5410048" cy="4023360"/>
+          </a:xfrm>
+          <a:prstGeom prst="rect">
+            <a:avLst/>
+          </a:prstGeom>
+          <a:noFill/>
+          <a:ln/>
+        </p:spPr>
+        <p:txBody>
+          <a:bodyPr wrap="square" lIns="0" tIns="0" rIns="0" bIns="0" rtlCol="0" anchor="t"/>
+          <a:lstStyle/>
+          <a:p>
+            <a:pPr indent="0" marL="0">
+              <a:spcAft>
+                <a:spcPts val="600"/>
+              </a:spcAft>
+              <a:buNone/>
+            </a:pPr>
+            <a:r>
+              <a:rPr lang="en-US" sz="1100" dirty="0">
+                <a:solidFill>
+                  <a:schemeClr val="bg1"/>
+                </a:solidFill>
+                <a:latin typeface="Arial" pitchFamily="34" charset="0"/>
+                <a:ea typeface="Arial" pitchFamily="34" charset="-122"/>
+                <a:cs typeface="Arial" pitchFamily="34" charset="-120"/>
+              </a:rPr>
+              <a:t>documenta: Retrospektive documenta 5 (1972). documenta.de/en/retrospective/documenta-5</a:t>
+            </a:r>
+            <a:endParaRPr lang="en-US" sz="1100" dirty="0"/>
+          </a:p>
+          <a:p>
+            <a:pPr indent="0" marL="0">
+              <a:spcAft>
+                <a:spcPts val="600"/>
+              </a:spcAft>
+              <a:buNone/>
+            </a:pPr>
+            <a:r>
+              <a:rPr lang="en-US" sz="1100" dirty="0">
+                <a:solidFill>
+                  <a:schemeClr val="bg1"/>
+                </a:solidFill>
+                <a:latin typeface="Arial" pitchFamily="34" charset="0"/>
+                <a:ea typeface="Arial" pitchFamily="34" charset="-122"/>
+                <a:cs typeface="Arial" pitchFamily="34" charset="-120"/>
+              </a:rPr>
+              <a:t>Louis K. Meisel Gallery: Curating the Stuart M. Speiser Collection. meiselgallery.com/story/curating-the-stuart-m-speiser-collection</a:t>
+            </a:r>
+            <a:endParaRPr lang="en-US" sz="1100" dirty="0"/>
+          </a:p>
+          <a:p>
+            <a:pPr indent="0" marL="0">
+              <a:spcAft>
+                <a:spcPts val="600"/>
+              </a:spcAft>
+              <a:buNone/>
+            </a:pPr>
+            <a:r>
+              <a:rPr lang="en-US" sz="1100" dirty="0">
+                <a:solidFill>
+                  <a:schemeClr val="bg1"/>
+                </a:solidFill>
+                <a:latin typeface="Arial" pitchFamily="34" charset="0"/>
+                <a:ea typeface="Arial" pitchFamily="34" charset="-122"/>
+                <a:cs typeface="Arial" pitchFamily="34" charset="-120"/>
+              </a:rPr>
+              <a:t>Museum Frieder Burda: Pressemitteilung „Wettstreit mit der Wirklichkeit“ (2026). museum-frieder-burda.de</a:t>
+            </a:r>
+            <a:endParaRPr lang="en-US" sz="1100" dirty="0"/>
+          </a:p>
+          <a:p>
+            <a:pPr indent="0" marL="0">
+              <a:spcAft>
+                <a:spcPts val="600"/>
+              </a:spcAft>
+              <a:buNone/>
+            </a:pPr>
+            <a:r>
+              <a:rPr lang="en-US" sz="1100" dirty="0">
+                <a:solidFill>
+                  <a:schemeClr val="bg1"/>
+                </a:solidFill>
+                <a:latin typeface="Arial" pitchFamily="34" charset="0"/>
+                <a:ea typeface="Arial" pitchFamily="34" charset="-122"/>
+                <a:cs typeface="Arial" pitchFamily="34" charset="-120"/>
+              </a:rPr>
+              <a:t>Tate: Art Term „Photorealism“. tate.org.uk/art/art-terms/photorealism</a:t>
+            </a:r>
+            <a:endParaRPr lang="en-US" sz="1100" dirty="0"/>
+          </a:p>
+          <a:p>
+            <a:pPr indent="0" marL="0">
+              <a:spcAft>
+                <a:spcPts val="600"/>
+              </a:spcAft>
+              <a:buNone/>
+            </a:pPr>
+            <a:r>
+              <a:rPr lang="en-US" sz="1100" dirty="0">
+                <a:solidFill>
+                  <a:schemeClr val="bg1"/>
+                </a:solidFill>
+                <a:latin typeface="Arial" pitchFamily="34" charset="0"/>
+                <a:ea typeface="Arial" pitchFamily="34" charset="-122"/>
+                <a:cs typeface="Arial" pitchFamily="34" charset="-120"/>
+              </a:rPr>
+              <a:t>The Art Story: Photorealism. theartstory.org/movement/photorealism</a:t>
+            </a:r>
+            <a:endParaRPr lang="en-US" sz="1100" dirty="0"/>
+          </a:p>
+          <a:p>
+            <a:pPr indent="0" marL="0">
+              <a:spcAft>
+                <a:spcPts val="600"/>
+              </a:spcAft>
+              <a:buNone/>
+            </a:pPr>
+            <a:r>
+              <a:rPr lang="en-US" sz="1100" dirty="0">
+                <a:solidFill>
+                  <a:schemeClr val="bg1"/>
+                </a:solidFill>
+                <a:latin typeface="Arial" pitchFamily="34" charset="0"/>
+                <a:ea typeface="Arial" pitchFamily="34" charset="-122"/>
+                <a:cs typeface="Arial" pitchFamily="34" charset="-120"/>
+              </a:rPr>
+              <a:t>Wikipedia: Fotorealismus. de.wikipedia.org/wiki/Fotorealismus</a:t>
+            </a:r>
+            <a:endParaRPr lang="en-US" sz="1100" dirty="0"/>
+          </a:p>
+          <a:p>
+            <a:pPr indent="0" marL="0">
+              <a:spcAft>
+                <a:spcPts val="600"/>
+              </a:spcAft>
+              <a:buNone/>
+            </a:pPr>
+            <a:r>
+              <a:rPr lang="en-US" sz="1100" dirty="0">
+                <a:solidFill>
+                  <a:schemeClr val="bg1"/>
+                </a:solidFill>
+                <a:latin typeface="Arial" pitchFamily="34" charset="0"/>
+                <a:ea typeface="Arial" pitchFamily="34" charset="-122"/>
+                <a:cs typeface="Arial" pitchFamily="34" charset="-120"/>
+              </a:rPr>
+              <a:t>Wikipedia: Hyperrealism (visual arts). en.wikipedia.org/wiki/Hyperrealism_(visual_arts)</a:t>
+            </a:r>
+            <a:endParaRPr lang="en-US" sz="1100" dirty="0"/>
+          </a:p>
+          <a:p>
+            <a:pPr indent="0" marL="0">
+              <a:spcAft>
+                <a:spcPts val="600"/>
+              </a:spcAft>
+              <a:buNone/>
+            </a:pPr>
+            <a:r>
+              <a:rPr lang="en-US" sz="1100" dirty="0">
+                <a:solidFill>
+                  <a:schemeClr val="bg1"/>
+                </a:solidFill>
+                <a:latin typeface="Arial" pitchFamily="34" charset="0"/>
+                <a:ea typeface="Arial" pitchFamily="34" charset="-122"/>
+                <a:cs typeface="Arial" pitchFamily="34" charset="-120"/>
+              </a:rPr>
+              <a:t>Alle Internetquellen abgerufen am 25.10.2026.</a:t>
             </a:r>
             <a:endParaRPr lang="en-US" sz="1100" dirty="0"/>
           </a:p>
@@ -12535,14 +12755,14 @@
       </p:grpSpPr>
       <p:sp>
         <p:nvSpPr>
-          <p:cNvPr id="2" name="Bildplatzhalter goings_diner"/>
-          <p:cNvSpPr/>
-          <p:nvPr/>
-        </p:nvSpPr>
-        <p:spPr>
-          <a:xfrm>
-            <a:off x="4987138" y="640080"/>
-            <a:ext cx="6653174" cy="4892040"/>
+          <p:cNvPr id="2" name="Bildplatzhalter goings_airstream"/>
+          <p:cNvSpPr/>
+          <p:nvPr/>
+        </p:nvSpPr>
+        <p:spPr>
+          <a:xfrm>
+            <a:off x="4791456" y="640080"/>
+            <a:ext cx="6848856" cy="4892040"/>
           </a:xfrm>
           <a:prstGeom prst="rect">
             <a:avLst/>
@@ -12574,7 +12794,7 @@
         </p:blipFill>
         <p:spPr>
           <a:xfrm>
-            <a:off x="8062265" y="2537460"/>
+            <a:off x="7964424" y="2537460"/>
             <a:ext cx="502920" cy="502920"/>
           </a:xfrm>
           <a:prstGeom prst="rect">
@@ -12590,8 +12810,8 @@
         </p:nvSpPr>
         <p:spPr>
           <a:xfrm>
-            <a:off x="5124298" y="3104388"/>
-            <a:ext cx="6378854" cy="731520"/>
+            <a:off x="4928616" y="3104388"/>
+            <a:ext cx="6574536" cy="731520"/>
           </a:xfrm>
           <a:prstGeom prst="rect">
             <a:avLst/>
@@ -12634,7 +12854,7 @@
                 <a:ea typeface="Arial" pitchFamily="34" charset="-122"/>
                 <a:cs typeface="Arial" pitchFamily="34" charset="-120"/>
               </a:rPr>
-              <a:t>Ralph Goings: Ralph's Diner</a:t>
+              <a:t>Ralph Goings: Airstream</a:t>
             </a:r>
             <a:endParaRPr lang="en-US" sz="1100" dirty="0"/>
           </a:p>
@@ -12648,7 +12868,7 @@
         </p:nvSpPr>
         <p:spPr>
           <a:xfrm>
-            <a:off x="4895698" y="548640"/>
+            <a:off x="4700016" y="548640"/>
             <a:ext cx="237744" cy="0"/>
           </a:xfrm>
           <a:prstGeom prst="line">
@@ -12671,7 +12891,7 @@
         </p:nvSpPr>
         <p:spPr>
           <a:xfrm>
-            <a:off x="4895698" y="548640"/>
+            <a:off x="4700016" y="548640"/>
             <a:ext cx="0" cy="237744"/>
           </a:xfrm>
           <a:prstGeom prst="line">
@@ -12740,7 +12960,7 @@
         </p:nvSpPr>
         <p:spPr>
           <a:xfrm>
-            <a:off x="4895698" y="5623560"/>
+            <a:off x="4700016" y="5623560"/>
             <a:ext cx="237744" cy="0"/>
           </a:xfrm>
           <a:prstGeom prst="line">
@@ -12763,7 +12983,7 @@
         </p:nvSpPr>
         <p:spPr>
           <a:xfrm>
-            <a:off x="4895698" y="5385816"/>
+            <a:off x="4700016" y="5385816"/>
             <a:ext cx="0" cy="237744"/>
           </a:xfrm>
           <a:prstGeom prst="line">
@@ -12910,8 +13130,8 @@
         </p:nvSpPr>
         <p:spPr>
           <a:xfrm>
-            <a:off x="4987138" y="5715000"/>
-            <a:ext cx="6653174" cy="502920"/>
+            <a:off x="4791456" y="5715000"/>
+            <a:ext cx="6848856" cy="502920"/>
           </a:xfrm>
           <a:prstGeom prst="rect">
             <a:avLst/>
@@ -12955,7 +13175,7 @@
                 <a:ea typeface="Arial" pitchFamily="34" charset="-122"/>
                 <a:cs typeface="Arial" pitchFamily="34" charset="-120"/>
               </a:rPr>
-              <a:t>Ralph's Diner</a:t>
+              <a:t>Airstream</a:t>
             </a:r>
             <a:pPr indent="0" marL="0">
               <a:spcAft>
@@ -12972,7 +13192,7 @@
                 <a:ea typeface="Arial" pitchFamily="34" charset="-122"/>
                 <a:cs typeface="Arial" pitchFamily="34" charset="-120"/>
               </a:rPr>
-              <a:t> (Ralphs Diner), 1981–82</a:t>
+              <a:t> (Airstream-Wohnwagen), 1970</a:t>
             </a:r>
             <a:endParaRPr lang="en-US" sz="1300" dirty="0"/>
           </a:p>
@@ -12992,7 +13212,7 @@
                 <a:ea typeface="Arial" pitchFamily="34" charset="-122"/>
                 <a:cs typeface="Arial" pitchFamily="34" charset="-120"/>
               </a:rPr>
-              <a:t>Öl auf Leinwand, 112 × 152 cm · Privatsammlung</a:t>
+              <a:t>Öl auf Leinwand, 152,3 × 213,5 cm · mumok Wien (Leihgabe Sammlung Ludwig, Aachen)</a:t>
             </a:r>
             <a:endParaRPr lang="en-US" sz="1300" dirty="0"/>
           </a:p>
@@ -13189,32 +13409,10 @@
                 <a:ea typeface="Arial" pitchFamily="34" charset="-122"/>
                 <a:cs typeface="Arial" pitchFamily="34" charset="-120"/>
               </a:rPr>
-              <a:t>(wird nach der Recherche ergänzt)</a:t>
+              <a:t>Folie 2: Ralph Goings, Airstream, 1970. mumok Wien (Leihgabe Sammlung Ludwig, Aachen). Abb.: mumok.at/en/online-collection/detail/airstream-1355</a:t>
             </a:r>
             <a:endParaRPr lang="en-US" sz="1000" dirty="0"/>
           </a:p>
-        </p:txBody>
-      </p:sp>
-      <p:sp>
-        <p:nvSpPr>
-          <p:cNvPr id="5" name="Text 3"/>
-          <p:cNvSpPr txBox="1"/>
-          <p:nvPr/>
-        </p:nvSpPr>
-        <p:spPr>
-          <a:xfrm>
-            <a:off x="6233008" y="1691640"/>
-            <a:ext cx="5410048" cy="4480560"/>
-          </a:xfrm>
-          <a:prstGeom prst="rect">
-            <a:avLst/>
-          </a:prstGeom>
-          <a:noFill/>
-          <a:ln/>
-        </p:spPr>
-        <p:txBody>
-          <a:bodyPr wrap="square" lIns="0" tIns="0" rIns="0" bIns="0" rtlCol="0" anchor="t"/>
-          <a:lstStyle/>
           <a:p>
             <a:pPr indent="0" marL="0">
               <a:spcAft>
@@ -13222,6 +13420,279 @@
               </a:spcAft>
               <a:buNone/>
             </a:pPr>
+            <a:r>
+              <a:rPr lang="en-US" sz="1000" dirty="0">
+                <a:solidFill>
+                  <a:schemeClr val="bg1"/>
+                </a:solidFill>
+                <a:latin typeface="Arial" pitchFamily="34" charset="0"/>
+                <a:ea typeface="Arial" pitchFamily="34" charset="-122"/>
+                <a:cs typeface="Arial" pitchFamily="34" charset="-120"/>
+              </a:rPr>
+              <a:t>Folie 7: Richard Estes, Telephone Booths, 1967. Museo Nacional Thyssen-Bornemisza, Madrid. Abb.: museothyssen.org/en/collection/artists/estes-richard/telephone-booths</a:t>
+            </a:r>
+            <a:endParaRPr lang="en-US" sz="1000" dirty="0"/>
+          </a:p>
+          <a:p>
+            <a:pPr indent="0" marL="0">
+              <a:spcAft>
+                <a:spcPts val="500"/>
+              </a:spcAft>
+              <a:buNone/>
+            </a:pPr>
+            <a:r>
+              <a:rPr lang="en-US" sz="1000" dirty="0">
+                <a:solidFill>
+                  <a:schemeClr val="bg1"/>
+                </a:solidFill>
+                <a:latin typeface="Arial" pitchFamily="34" charset="0"/>
+                <a:ea typeface="Arial" pitchFamily="34" charset="-122"/>
+                <a:cs typeface="Arial" pitchFamily="34" charset="-120"/>
+              </a:rPr>
+              <a:t>Folie 8: Chuck Close, Big Self-Portrait, 1967–68. Walker Art Center, Minneapolis. Abb.: walkerart.org/collections/artworks/big-self-portrait</a:t>
+            </a:r>
+            <a:endParaRPr lang="en-US" sz="1000" dirty="0"/>
+          </a:p>
+          <a:p>
+            <a:pPr indent="0" marL="0">
+              <a:spcAft>
+                <a:spcPts val="500"/>
+              </a:spcAft>
+              <a:buNone/>
+            </a:pPr>
+            <a:r>
+              <a:rPr lang="en-US" sz="1000" dirty="0">
+                <a:solidFill>
+                  <a:schemeClr val="bg1"/>
+                </a:solidFill>
+                <a:latin typeface="Arial" pitchFamily="34" charset="0"/>
+                <a:ea typeface="Arial" pitchFamily="34" charset="-122"/>
+                <a:cs typeface="Arial" pitchFamily="34" charset="-120"/>
+              </a:rPr>
+              <a:t>Folie 13: Malcolm Morley, SS Amsterdam in Front of Rotterdam, 1966. Privatsammlung. Abb.: petzel.com/collect/malcolm-morley4</a:t>
+            </a:r>
+            <a:endParaRPr lang="en-US" sz="1000" dirty="0"/>
+          </a:p>
+          <a:p>
+            <a:pPr indent="0" marL="0">
+              <a:spcAft>
+                <a:spcPts val="500"/>
+              </a:spcAft>
+              <a:buNone/>
+            </a:pPr>
+            <a:r>
+              <a:rPr lang="en-US" sz="1000" dirty="0">
+                <a:solidFill>
+                  <a:schemeClr val="bg1"/>
+                </a:solidFill>
+                <a:latin typeface="Arial" pitchFamily="34" charset="0"/>
+                <a:ea typeface="Arial" pitchFamily="34" charset="-122"/>
+                <a:cs typeface="Arial" pitchFamily="34" charset="-120"/>
+              </a:rPr>
+              <a:t>Folie 13: Franz Gertsch, Medici, 1971/72. Ludwig Forum für Internationale Kunst, Aachen. Abb.: guide.kunstmuseumbern.ch/en/artwork/12884</a:t>
+            </a:r>
+            <a:endParaRPr lang="en-US" sz="1000" dirty="0"/>
+          </a:p>
+          <a:p>
+            <a:pPr indent="0" marL="0">
+              <a:spcAft>
+                <a:spcPts val="500"/>
+              </a:spcAft>
+              <a:buNone/>
+            </a:pPr>
+            <a:r>
+              <a:rPr lang="en-US" sz="1000" dirty="0">
+                <a:solidFill>
+                  <a:schemeClr val="bg1"/>
+                </a:solidFill>
+                <a:latin typeface="Arial" pitchFamily="34" charset="0"/>
+                <a:ea typeface="Arial" pitchFamily="34" charset="-122"/>
+                <a:cs typeface="Arial" pitchFamily="34" charset="-120"/>
+              </a:rPr>
+              <a:t>Folie 14: Robert Bechtle, ’61 Pontiac, 1968–69. Whitney Museum of American Art, New York. Abb.: whitney.org/collection/works/493</a:t>
+            </a:r>
+            <a:endParaRPr lang="en-US" sz="1000" dirty="0"/>
+          </a:p>
+          <a:p>
+            <a:pPr indent="0" marL="0">
+              <a:spcAft>
+                <a:spcPts val="500"/>
+              </a:spcAft>
+              <a:buNone/>
+            </a:pPr>
+            <a:r>
+              <a:rPr lang="en-US" sz="1000" dirty="0">
+                <a:solidFill>
+                  <a:schemeClr val="bg1"/>
+                </a:solidFill>
+                <a:latin typeface="Arial" pitchFamily="34" charset="0"/>
+                <a:ea typeface="Arial" pitchFamily="34" charset="-122"/>
+                <a:cs typeface="Arial" pitchFamily="34" charset="-120"/>
+              </a:rPr>
+              <a:t>Folie 14: Don Eddy, New Shoes for H, 1973–74. Cleveland Museum of Art. Abb.: clevelandart.org/art/1974.53</a:t>
+            </a:r>
+            <a:endParaRPr lang="en-US" sz="1000" dirty="0"/>
+          </a:p>
+        </p:txBody>
+      </p:sp>
+      <p:sp>
+        <p:nvSpPr>
+          <p:cNvPr id="5" name="Text 3"/>
+          <p:cNvSpPr txBox="1"/>
+          <p:nvPr/>
+        </p:nvSpPr>
+        <p:spPr>
+          <a:xfrm>
+            <a:off x="6233008" y="1691640"/>
+            <a:ext cx="5410048" cy="4480560"/>
+          </a:xfrm>
+          <a:prstGeom prst="rect">
+            <a:avLst/>
+          </a:prstGeom>
+          <a:noFill/>
+          <a:ln/>
+        </p:spPr>
+        <p:txBody>
+          <a:bodyPr wrap="square" lIns="0" tIns="0" rIns="0" bIns="0" rtlCol="0" anchor="t"/>
+          <a:lstStyle/>
+          <a:p>
+            <a:pPr indent="0" marL="0">
+              <a:spcAft>
+                <a:spcPts val="500"/>
+              </a:spcAft>
+              <a:buNone/>
+            </a:pPr>
+            <a:r>
+              <a:rPr lang="en-US" sz="1000" dirty="0">
+                <a:solidFill>
+                  <a:schemeClr val="bg1"/>
+                </a:solidFill>
+                <a:latin typeface="Arial" pitchFamily="34" charset="0"/>
+                <a:ea typeface="Arial" pitchFamily="34" charset="-122"/>
+                <a:cs typeface="Arial" pitchFamily="34" charset="-120"/>
+              </a:rPr>
+              <a:t>Folie 15: Audrey Flack, Marilyn (Vanitas), 1977. University of Arizona Museum of Art, Tucson. Abb.: uarizona.pastperfectonline.com (Inv.-Nr. 1982.035.001)</a:t>
+            </a:r>
+            <a:endParaRPr lang="en-US" sz="1000" dirty="0"/>
+          </a:p>
+          <a:p>
+            <a:pPr indent="0" marL="0">
+              <a:spcAft>
+                <a:spcPts val="500"/>
+              </a:spcAft>
+              <a:buNone/>
+            </a:pPr>
+            <a:r>
+              <a:rPr lang="en-US" sz="1000" dirty="0">
+                <a:solidFill>
+                  <a:schemeClr val="bg1"/>
+                </a:solidFill>
+                <a:latin typeface="Arial" pitchFamily="34" charset="0"/>
+                <a:ea typeface="Arial" pitchFamily="34" charset="-122"/>
+                <a:cs typeface="Arial" pitchFamily="34" charset="-120"/>
+              </a:rPr>
+              <a:t>Folie 15: Charles Bell, Gum Ball No. 10: „Sugar Daddy“, 1975. Solomon R. Guggenheim Museum, New York. Abb.: guggenheim.org/artwork/artist/charles-bell</a:t>
+            </a:r>
+            <a:endParaRPr lang="en-US" sz="1000" dirty="0"/>
+          </a:p>
+          <a:p>
+            <a:pPr indent="0" marL="0">
+              <a:spcAft>
+                <a:spcPts val="500"/>
+              </a:spcAft>
+              <a:buNone/>
+            </a:pPr>
+            <a:r>
+              <a:rPr lang="en-US" sz="1000" dirty="0">
+                <a:solidFill>
+                  <a:schemeClr val="bg1"/>
+                </a:solidFill>
+                <a:latin typeface="Arial" pitchFamily="34" charset="0"/>
+                <a:ea typeface="Arial" pitchFamily="34" charset="-122"/>
+                <a:cs typeface="Arial" pitchFamily="34" charset="-120"/>
+              </a:rPr>
+              <a:t>Folie 16: Duane Hanson, Supermarket Lady, 1969/70. Ludwig Forum für Internationale Kunst, Aachen. Abb.: ludwigforum.de/en/museum/restoration-workshop/supermarket-lady</a:t>
+            </a:r>
+            <a:endParaRPr lang="en-US" sz="1000" dirty="0"/>
+          </a:p>
+          <a:p>
+            <a:pPr indent="0" marL="0">
+              <a:spcAft>
+                <a:spcPts val="500"/>
+              </a:spcAft>
+              <a:buNone/>
+            </a:pPr>
+            <a:r>
+              <a:rPr lang="en-US" sz="1000" dirty="0">
+                <a:solidFill>
+                  <a:schemeClr val="bg1"/>
+                </a:solidFill>
+                <a:latin typeface="Arial" pitchFamily="34" charset="0"/>
+                <a:ea typeface="Arial" pitchFamily="34" charset="-122"/>
+                <a:cs typeface="Arial" pitchFamily="34" charset="-120"/>
+              </a:rPr>
+              <a:t>Folie 16: Ron Mueck, Mask II, 2001–02. San Francisco Museum of Modern Art. Abb.: sfmoma.org (Art Supporting Foundation to SFMOMA)</a:t>
+            </a:r>
+            <a:endParaRPr lang="en-US" sz="1000" dirty="0"/>
+          </a:p>
+          <a:p>
+            <a:pPr indent="0" marL="0">
+              <a:spcAft>
+                <a:spcPts val="500"/>
+              </a:spcAft>
+              <a:buNone/>
+            </a:pPr>
+            <a:r>
+              <a:rPr lang="en-US" sz="1000" dirty="0">
+                <a:solidFill>
+                  <a:schemeClr val="bg1"/>
+                </a:solidFill>
+                <a:latin typeface="Arial" pitchFamily="34" charset="0"/>
+                <a:ea typeface="Arial" pitchFamily="34" charset="-122"/>
+                <a:cs typeface="Arial" pitchFamily="34" charset="-120"/>
+              </a:rPr>
+              <a:t>Folie 17: Gottfried Helnwein, Epiphany II (Adoration of the Shepherds), 1998. de Young Museum, San Francisco. Abb.: famsf.org/artworks/epiphany-ii-adoration-of-the-shepherds</a:t>
+            </a:r>
+            <a:endParaRPr lang="en-US" sz="1000" dirty="0"/>
+          </a:p>
+          <a:p>
+            <a:pPr indent="0" marL="0">
+              <a:spcAft>
+                <a:spcPts val="500"/>
+              </a:spcAft>
+              <a:buNone/>
+            </a:pPr>
+            <a:r>
+              <a:rPr lang="en-US" sz="1000" dirty="0">
+                <a:solidFill>
+                  <a:schemeClr val="bg1"/>
+                </a:solidFill>
+                <a:latin typeface="Arial" pitchFamily="34" charset="0"/>
+                <a:ea typeface="Arial" pitchFamily="34" charset="-122"/>
+                <a:cs typeface="Arial" pitchFamily="34" charset="-120"/>
+              </a:rPr>
+              <a:t>Folie 17: Gregory Thielker, Exhale, 2023. Guy Hepner Gallery, New York. Abb.: guyhepner.com/artworks/9873-gregory-thielker-exhale-2023</a:t>
+            </a:r>
+            <a:endParaRPr lang="en-US" sz="1000" dirty="0"/>
+          </a:p>
+          <a:p>
+            <a:pPr indent="0" marL="0">
+              <a:spcAft>
+                <a:spcPts val="500"/>
+              </a:spcAft>
+              <a:buNone/>
+            </a:pPr>
+            <a:r>
+              <a:rPr lang="en-US" sz="1000" dirty="0">
+                <a:solidFill>
+                  <a:schemeClr val="bg1"/>
+                </a:solidFill>
+                <a:latin typeface="Arial" pitchFamily="34" charset="0"/>
+                <a:ea typeface="Arial" pitchFamily="34" charset="-122"/>
+                <a:cs typeface="Arial" pitchFamily="34" charset="-120"/>
+              </a:rPr>
+              <a:t>Abbildungen nur zu Unterrichtszwecken (§ 60a UrhG); Rechte bei den Künstlern bzw. Nachlässen. Webseiten abgerufen am 25.10.2026.</a:t>
+            </a:r>
             <a:endParaRPr lang="en-US" sz="1000" dirty="0"/>
           </a:p>
         </p:txBody>
@@ -14419,7 +14890,7 @@
                 <a:ea typeface="Arial" pitchFamily="34" charset="-122"/>
                 <a:cs typeface="Arial" pitchFamily="34" charset="-120"/>
               </a:rPr>
-              <a:t>Pop Art holt Werbung, Konsum und Medienbilder in die Kunst.</a:t>
+              <a:t>Pop Art holt Werbung und Konsum in die Kunst – Gegenpol zur abstrakten Malerei.</a:t>
             </a:r>
             <a:endParaRPr lang="en-US" sz="2200" dirty="0"/>
           </a:p>
@@ -14749,7 +15220,7 @@
                 <a:ea typeface="Arial" pitchFamily="34" charset="-122"/>
                 <a:cs typeface="Arial" pitchFamily="34" charset="-120"/>
               </a:rPr>
-              <a:t>documenta 5 in Kassel: Durchbruch in Europa.</a:t>
+              <a:t>documenta 5 in Kassel: erster großer Auftritt in Europa.</a:t>
             </a:r>
             <a:endParaRPr lang="en-US" sz="2200" dirty="0"/>
           </a:p>
@@ -14859,7 +15330,7 @@
                 <a:ea typeface="Arial" pitchFamily="34" charset="-122"/>
                 <a:cs typeface="Arial" pitchFamily="34" charset="-120"/>
               </a:rPr>
-              <a:t>Ausstellung in Brüssel (Galerie Isy Brachot) prägt „Hyperrealismus“.</a:t>
+              <a:t>Ausstellung „Hyperréalisme“ in Brüssel (Galerie Isy Brachot) prägt den Begriff.</a:t>
             </a:r>
             <a:endParaRPr lang="en-US" sz="2200" dirty="0"/>
           </a:p>
@@ -14969,7 +15440,7 @@
                 <a:ea typeface="Arial" pitchFamily="34" charset="-122"/>
                 <a:cs typeface="Arial" pitchFamily="34" charset="-120"/>
               </a:rPr>
-              <a:t>Meisels Buch „Photorealism“ legt fünf Kriterien fest.</a:t>
+              <a:t>Meisels Standardwerk „Photo-Realism“ fasst die erste Generation zusammen.</a:t>
             </a:r>
             <a:endParaRPr lang="en-US" sz="2200" dirty="0"/>
           </a:p>
@@ -15079,7 +15550,7 @@
                 <a:ea typeface="Arial" pitchFamily="34" charset="-122"/>
                 <a:cs typeface="Arial" pitchFamily="34" charset="-120"/>
               </a:rPr>
-              <a:t>Hyperrealismus boomt: Digitalfotos, Skulpturen aus Silikon.</a:t>
+              <a:t>Hyperrealismus boomt: Digitalfotos, Skulpturen aus Silikon (Ron Mueck).</a:t>
             </a:r>
             <a:endParaRPr lang="en-US" sz="2200" dirty="0"/>
           </a:p>
@@ -15482,7 +15953,7 @@
                 <a:ea typeface="Arial" pitchFamily="34" charset="-122"/>
                 <a:cs typeface="Arial" pitchFamily="34" charset="-120"/>
               </a:rPr>
-              <a:t>ca. 1966–1980 · zuerst USA, dann Europa</a:t>
+              <a:t>Ende 1960er bis ca. 1980 · USA, dann Europa</a:t>
             </a:r>
             <a:endParaRPr lang="en-US" sz="2200" dirty="0"/>
           </a:p>
@@ -16689,7 +17160,7 @@
                 <a:ea typeface="Arial" pitchFamily="34" charset="-122"/>
                 <a:cs typeface="Arial" pitchFamily="34" charset="-120"/>
               </a:rPr>
-              <a:t>Rasternetz oder Projektor übertragen das Foto exakt auf die Leinwand.</a:t>
+              <a:t>Rasternetz oder Diaprojektor übertragen das Foto genau auf die Leinwand.</a:t>
             </a:r>
             <a:endParaRPr lang="en-US" sz="1600" dirty="0"/>
           </a:p>
@@ -16993,7 +17464,7 @@
                 <a:ea typeface="Arial" pitchFamily="34" charset="-122"/>
                 <a:cs typeface="Arial" pitchFamily="34" charset="-120"/>
               </a:rPr>
-              <a:t>Ausschnitt, Licht, Spiegelungen und sogar Unschärfe werden vom Foto übernommen.</a:t>
+              <a:t>Ausschnitt, Licht und Spiegelungen – manchmal sogar die Unschärfe – stammen aus dem Foto.</a:t>
             </a:r>
             <a:endParaRPr lang="en-US" sz="1600" dirty="0"/>
           </a:p>
@@ -18079,7 +18550,7 @@
                 <a:ea typeface="Arial" pitchFamily="34" charset="-122"/>
                 <a:cs typeface="Arial" pitchFamily="34" charset="-120"/>
               </a:rPr>
-              <a:t>Vorne und hinten ist alles gleich scharf.</a:t>
+              <a:t>Nah und fern gleich scharf – mehr, als Auge oder Kamera schaffen.</a:t>
             </a:r>
             <a:endParaRPr lang="en-US" sz="1500" dirty="0"/>
           </a:p>
@@ -18422,7 +18893,7 @@
                 <a:ea typeface="Arial" pitchFamily="34" charset="-122"/>
                 <a:cs typeface="Arial" pitchFamily="34" charset="-120"/>
               </a:rPr>
-              <a:t>Foto als Vorlage</a:t>
+              <a:t>Mehrere Fotos als Vorlage</a:t>
             </a:r>
             <a:endParaRPr lang="en-US" sz="1500" dirty="0"/>
           </a:p>
@@ -18439,7 +18910,7 @@
                 <a:ea typeface="Arial" pitchFamily="34" charset="-122"/>
                 <a:cs typeface="Arial" pitchFamily="34" charset="-120"/>
               </a:rPr>
-              <a:t>Estes arbeitet nach eigenen Fotos und kombiniert oft mehrere.</a:t>
+              <a:t>Estes malt ohne Projektor und setzt mehrere eigene Fotos zusammen.</a:t>
             </a:r>
             <a:endParaRPr lang="en-US" sz="1500" dirty="0"/>
           </a:p>
@@ -18961,7 +19432,7 @@
                 <a:ea typeface="Arial" pitchFamily="34" charset="-122"/>
                 <a:cs typeface="Arial" pitchFamily="34" charset="-120"/>
               </a:rPr>
-              <a:t> (Großes Selbstporträt), 1967–68</a:t>
+              <a:t> (Großes Selbstbildnis), 1967–68</a:t>
             </a:r>
             <a:endParaRPr lang="en-US" sz="1300" dirty="0"/>
           </a:p>
@@ -18981,7 +19452,7 @@
                 <a:ea typeface="Arial" pitchFamily="34" charset="-122"/>
                 <a:cs typeface="Arial" pitchFamily="34" charset="-120"/>
               </a:rPr>
-              <a:t>Acryl auf Leinwand, 273 × 212 cm · Walker Art Center, Minneapolis</a:t>
+              <a:t>Acryl auf Leinwand (Airbrush), 273,1 × 212,1 cm · Walker Art Center, Minneapolis</a:t>
             </a:r>
             <a:endParaRPr lang="en-US" sz="1300" dirty="0"/>
           </a:p>
@@ -18995,8 +19466,8 @@
         </p:nvSpPr>
         <p:spPr>
           <a:xfrm>
-            <a:off x="5394960" y="1691640"/>
-            <a:ext cx="2926080" cy="914400"/>
+            <a:off x="5257800" y="1691640"/>
+            <a:ext cx="3108960" cy="960120"/>
           </a:xfrm>
           <a:prstGeom prst="rect">
             <a:avLst/>
@@ -19012,7 +19483,7 @@
               <a:buNone/>
             </a:pPr>
             <a:r>
-              <a:rPr lang="en-US" sz="6000" b="1" dirty="0">
+              <a:rPr lang="en-US" sz="6400" b="1" dirty="0">
                 <a:solidFill>
                   <a:schemeClr val="accent1"/>
                 </a:solidFill>
@@ -19022,7 +19493,7 @@
               </a:rPr>
               <a:t>2,73 m</a:t>
             </a:r>
-            <a:endParaRPr lang="en-US" sz="6000" dirty="0"/>
+            <a:endParaRPr lang="en-US" sz="6400" dirty="0"/>
           </a:p>
         </p:txBody>
       </p:sp>
@@ -19034,8 +19505,8 @@
         </p:nvSpPr>
         <p:spPr>
           <a:xfrm>
-            <a:off x="5394960" y="2651760"/>
-            <a:ext cx="2743200" cy="731520"/>
+            <a:off x="8503920" y="1892808"/>
+            <a:ext cx="3139135" cy="731520"/>
           </a:xfrm>
           <a:prstGeom prst="rect">
             <a:avLst/>
@@ -19051,7 +19522,7 @@
               <a:buNone/>
             </a:pPr>
             <a:r>
-              <a:rPr lang="en-US" sz="1400" dirty="0">
+              <a:rPr lang="en-US" sz="1600" dirty="0">
                 <a:solidFill>
                   <a:schemeClr val="bg2"/>
                 </a:solidFill>
@@ -19061,48 +19532,34 @@
               </a:rPr>
               <a:t>hoch – ein Gesicht in Monumentalgröße</a:t>
             </a:r>
-            <a:endParaRPr lang="en-US" sz="1400" dirty="0"/>
-          </a:p>
-        </p:txBody>
-      </p:sp>
-      <p:sp>
-        <p:nvSpPr>
-          <p:cNvPr id="18" name="Text 15"/>
-          <p:cNvSpPr txBox="1"/>
-          <p:nvPr/>
-        </p:nvSpPr>
-        <p:spPr>
-          <a:xfrm>
-            <a:off x="5394960" y="3703320"/>
-            <a:ext cx="2926080" cy="914400"/>
-          </a:xfrm>
-          <a:prstGeom prst="rect">
-            <a:avLst/>
-          </a:prstGeom>
-          <a:noFill/>
-          <a:ln/>
-        </p:spPr>
-        <p:txBody>
-          <a:bodyPr wrap="square" lIns="0" tIns="0" rIns="0" bIns="0" rtlCol="0" anchor="t"/>
-          <a:lstStyle/>
-          <a:p>
-            <a:pPr indent="0" marL="0">
-              <a:buNone/>
-            </a:pPr>
-            <a:r>
-              <a:rPr lang="en-US" sz="6000" b="1" dirty="0">
-                <a:solidFill>
-                  <a:schemeClr val="accent1"/>
-                </a:solidFill>
-                <a:latin typeface="Georgia" pitchFamily="34" charset="0"/>
-                <a:ea typeface="Georgia" pitchFamily="34" charset="-122"/>
-                <a:cs typeface="Georgia" pitchFamily="34" charset="-120"/>
-              </a:rPr>
-              <a:t>Raster</a:t>
-            </a:r>
-            <a:endParaRPr lang="en-US" sz="6000" dirty="0"/>
-          </a:p>
-        </p:txBody>
+            <a:endParaRPr lang="en-US" sz="1600" dirty="0"/>
+          </a:p>
+        </p:txBody>
+      </p:sp>
+      <p:sp>
+        <p:nvSpPr>
+          <p:cNvPr id="18" name="Shape 15"/>
+          <p:cNvSpPr/>
+          <p:nvPr/>
+        </p:nvSpPr>
+        <p:spPr>
+          <a:xfrm>
+            <a:off x="5257800" y="3017520"/>
+            <a:ext cx="3055468" cy="1325880"/>
+          </a:xfrm>
+          <a:prstGeom prst="rect">
+            <a:avLst/>
+          </a:prstGeom>
+          <a:solidFill>
+            <a:schemeClr val="tx2"/>
+          </a:solidFill>
+          <a:ln w="12700">
+            <a:solidFill>
+              <a:schemeClr val="tx2"/>
+            </a:solidFill>
+            <a:prstDash val="solid"/>
+          </a:ln>
+        </p:spPr>
       </p:sp>
       <p:sp>
         <p:nvSpPr>
@@ -19112,8 +19569,8 @@
         </p:nvSpPr>
         <p:spPr>
           <a:xfrm>
-            <a:off x="5394960" y="4663440"/>
-            <a:ext cx="2743200" cy="731520"/>
+            <a:off x="5486400" y="3200400"/>
+            <a:ext cx="2598268" cy="1051560"/>
           </a:xfrm>
           <a:prstGeom prst="rect">
             <a:avLst/>
@@ -19126,6 +19583,29 @@
           <a:lstStyle/>
           <a:p>
             <a:pPr indent="0" marL="0">
+              <a:spcAft>
+                <a:spcPts val="300"/>
+              </a:spcAft>
+              <a:buNone/>
+            </a:pPr>
+            <a:r>
+              <a:rPr lang="en-US" sz="1600" b="1" dirty="0">
+                <a:solidFill>
+                  <a:schemeClr val="bg1"/>
+                </a:solidFill>
+                <a:latin typeface="Arial" pitchFamily="34" charset="0"/>
+                <a:ea typeface="Arial" pitchFamily="34" charset="-122"/>
+                <a:cs typeface="Arial" pitchFamily="34" charset="-120"/>
+              </a:rPr>
+              <a:t>Raster</a:t>
+            </a:r>
+            <a:endParaRPr lang="en-US" sz="1600" dirty="0"/>
+          </a:p>
+          <a:p>
+            <a:pPr indent="0" marL="0">
+              <a:spcAft>
+                <a:spcPts val="300"/>
+              </a:spcAft>
               <a:buNone/>
             </a:pPr>
             <a:r>
@@ -19137,67 +19617,36 @@
                 <a:ea typeface="Arial" pitchFamily="34" charset="-122"/>
                 <a:cs typeface="Arial" pitchFamily="34" charset="-120"/>
               </a:rPr>
-              <a:t>Foto und Leinwand werden in Quadrate geteilt und Feld für Feld übertragen</a:t>
-            </a:r>
-            <a:endParaRPr lang="en-US" sz="1400" dirty="0"/>
-          </a:p>
-        </p:txBody>
-      </p:sp>
-      <p:sp>
-        <p:nvSpPr>
-          <p:cNvPr id="20" name="Text 17"/>
-          <p:cNvSpPr txBox="1"/>
-          <p:nvPr/>
-        </p:nvSpPr>
-        <p:spPr>
-          <a:xfrm>
-            <a:off x="8503920" y="1737360"/>
-            <a:ext cx="3139135" cy="1005840"/>
-          </a:xfrm>
-          <a:prstGeom prst="rect">
-            <a:avLst/>
-          </a:prstGeom>
-          <a:noFill/>
-          <a:ln/>
-        </p:spPr>
-        <p:txBody>
-          <a:bodyPr wrap="square" lIns="0" tIns="0" rIns="0" bIns="0" rtlCol="0" anchor="t"/>
-          <a:lstStyle/>
-          <a:p>
-            <a:pPr indent="0" marL="0">
-              <a:buNone/>
-            </a:pPr>
-            <a:r>
-              <a:rPr lang="en-US" sz="1500" b="1" dirty="0">
-                <a:solidFill>
-                  <a:schemeClr val="bg1"/>
-                </a:solidFill>
-                <a:latin typeface="Arial" pitchFamily="34" charset="0"/>
-                <a:ea typeface="Arial" pitchFamily="34" charset="-122"/>
-                <a:cs typeface="Arial" pitchFamily="34" charset="-120"/>
-              </a:rPr>
-              <a:t>Fotografische Unschärfe</a:t>
-            </a:r>
-            <a:endParaRPr lang="en-US" sz="1500" dirty="0"/>
-          </a:p>
-          <a:p>
-            <a:pPr indent="0" marL="0">
-              <a:buNone/>
-            </a:pPr>
-            <a:r>
-              <a:rPr lang="en-US" sz="1300" dirty="0">
-                <a:solidFill>
-                  <a:schemeClr val="bg2"/>
-                </a:solidFill>
-                <a:latin typeface="Arial" pitchFamily="34" charset="0"/>
-                <a:ea typeface="Arial" pitchFamily="34" charset="-122"/>
-                <a:cs typeface="Arial" pitchFamily="34" charset="-120"/>
-              </a:rPr>
-              <a:t>Gesicht scharf, Haare und Schultern verschwimmen – wie bei der Kamera.</a:t>
-            </a:r>
-            <a:endParaRPr lang="en-US" sz="1500" dirty="0"/>
-          </a:p>
-        </p:txBody>
+              <a:t>Foto und Leinwand werden in Quadrate geteilt und Feld für Feld übertragen.</a:t>
+            </a:r>
+            <a:endParaRPr lang="en-US" sz="1600" dirty="0"/>
+          </a:p>
+        </p:txBody>
+      </p:sp>
+      <p:sp>
+        <p:nvSpPr>
+          <p:cNvPr id="20" name="Shape 17"/>
+          <p:cNvSpPr/>
+          <p:nvPr/>
+        </p:nvSpPr>
+        <p:spPr>
+          <a:xfrm>
+            <a:off x="8587588" y="3017520"/>
+            <a:ext cx="3055468" cy="1325880"/>
+          </a:xfrm>
+          <a:prstGeom prst="rect">
+            <a:avLst/>
+          </a:prstGeom>
+          <a:solidFill>
+            <a:schemeClr val="tx2"/>
+          </a:solidFill>
+          <a:ln w="12700">
+            <a:solidFill>
+              <a:schemeClr val="tx2"/>
+            </a:solidFill>
+            <a:prstDash val="solid"/>
+          </a:ln>
+        </p:spPr>
       </p:sp>
       <p:sp>
         <p:nvSpPr>
@@ -19207,8 +19656,8 @@
         </p:nvSpPr>
         <p:spPr>
           <a:xfrm>
-            <a:off x="8503920" y="2834640"/>
-            <a:ext cx="3139135" cy="1005840"/>
+            <a:off x="8816188" y="3200400"/>
+            <a:ext cx="2598268" cy="1051560"/>
           </a:xfrm>
           <a:prstGeom prst="rect">
             <a:avLst/>
@@ -19221,10 +19670,13 @@
           <a:lstStyle/>
           <a:p>
             <a:pPr indent="0" marL="0">
-              <a:buNone/>
-            </a:pPr>
-            <a:r>
-              <a:rPr lang="en-US" sz="1500" b="1" dirty="0">
+              <a:spcAft>
+                <a:spcPts val="300"/>
+              </a:spcAft>
+              <a:buNone/>
+            </a:pPr>
+            <a:r>
+              <a:rPr lang="en-US" sz="1600" b="1" dirty="0">
                 <a:solidFill>
                   <a:schemeClr val="bg1"/>
                 </a:solidFill>
@@ -19234,14 +19686,17 @@
               </a:rPr>
               <a:t>Airbrush</a:t>
             </a:r>
-            <a:endParaRPr lang="en-US" sz="1500" dirty="0"/>
-          </a:p>
-          <a:p>
-            <a:pPr indent="0" marL="0">
-              <a:buNone/>
-            </a:pPr>
-            <a:r>
-              <a:rPr lang="en-US" sz="1300" dirty="0">
+            <a:endParaRPr lang="en-US" sz="1600" dirty="0"/>
+          </a:p>
+          <a:p>
+            <a:pPr indent="0" marL="0">
+              <a:spcAft>
+                <a:spcPts val="300"/>
+              </a:spcAft>
+              <a:buNone/>
+            </a:pPr>
+            <a:r>
+              <a:rPr lang="en-US" sz="1400" dirty="0">
                 <a:solidFill>
                   <a:schemeClr val="bg2"/>
                 </a:solidFill>
@@ -19249,22 +19704,47 @@
                 <a:ea typeface="Arial" pitchFamily="34" charset="-122"/>
                 <a:cs typeface="Arial" pitchFamily="34" charset="-120"/>
               </a:rPr>
-              <a:t>Mit der Spritzpistole in Schwarz-Weiß gemalt, ohne Pinselspur.</a:t>
-            </a:r>
-            <a:endParaRPr lang="en-US" sz="1500" dirty="0"/>
-          </a:p>
-        </p:txBody>
-      </p:sp>
-      <p:sp>
-        <p:nvSpPr>
-          <p:cNvPr id="22" name="Text 19"/>
+              <a:t>Mit der Spritzpistole in Schwarz-Weiß gemalt – keine Pinselspur.</a:t>
+            </a:r>
+            <a:endParaRPr lang="en-US" sz="1600" dirty="0"/>
+          </a:p>
+        </p:txBody>
+      </p:sp>
+      <p:sp>
+        <p:nvSpPr>
+          <p:cNvPr id="22" name="Shape 19"/>
+          <p:cNvSpPr/>
+          <p:nvPr/>
+        </p:nvSpPr>
+        <p:spPr>
+          <a:xfrm>
+            <a:off x="5257800" y="4617720"/>
+            <a:ext cx="3055468" cy="1325880"/>
+          </a:xfrm>
+          <a:prstGeom prst="rect">
+            <a:avLst/>
+          </a:prstGeom>
+          <a:solidFill>
+            <a:schemeClr val="tx2"/>
+          </a:solidFill>
+          <a:ln w="12700">
+            <a:solidFill>
+              <a:schemeClr val="tx2"/>
+            </a:solidFill>
+            <a:prstDash val="solid"/>
+          </a:ln>
+        </p:spPr>
+      </p:sp>
+      <p:sp>
+        <p:nvSpPr>
+          <p:cNvPr id="23" name="Text 20"/>
           <p:cNvSpPr txBox="1"/>
           <p:nvPr/>
         </p:nvSpPr>
         <p:spPr>
           <a:xfrm>
-            <a:off x="8503920" y="3931920"/>
-            <a:ext cx="3139135" cy="1005840"/>
+            <a:off x="5486400" y="4800600"/>
+            <a:ext cx="2598268" cy="1051560"/>
           </a:xfrm>
           <a:prstGeom prst="rect">
             <a:avLst/>
@@ -19277,10 +19757,13 @@
           <a:lstStyle/>
           <a:p>
             <a:pPr indent="0" marL="0">
-              <a:buNone/>
-            </a:pPr>
-            <a:r>
-              <a:rPr lang="en-US" sz="1500" b="1" dirty="0">
+              <a:spcAft>
+                <a:spcPts val="300"/>
+              </a:spcAft>
+              <a:buNone/>
+            </a:pPr>
+            <a:r>
+              <a:rPr lang="en-US" sz="1600" b="1" dirty="0">
                 <a:solidFill>
                   <a:schemeClr val="bg1"/>
                 </a:solidFill>
@@ -19288,16 +19771,19 @@
                 <a:ea typeface="Arial" pitchFamily="34" charset="-122"/>
                 <a:cs typeface="Arial" pitchFamily="34" charset="-120"/>
               </a:rPr>
-              <a:t>Schnappschuss-Ästhetik</a:t>
-            </a:r>
-            <a:endParaRPr lang="en-US" sz="1500" dirty="0"/>
-          </a:p>
-          <a:p>
-            <a:pPr indent="0" marL="0">
-              <a:buNone/>
-            </a:pPr>
-            <a:r>
-              <a:rPr lang="en-US" sz="1300" dirty="0">
+              <a:t>Fotografische Unschärfe</a:t>
+            </a:r>
+            <a:endParaRPr lang="en-US" sz="1600" dirty="0"/>
+          </a:p>
+          <a:p>
+            <a:pPr indent="0" marL="0">
+              <a:spcAft>
+                <a:spcPts val="300"/>
+              </a:spcAft>
+              <a:buNone/>
+            </a:pPr>
+            <a:r>
+              <a:rPr lang="en-US" sz="1400" dirty="0">
                 <a:solidFill>
                   <a:schemeClr val="bg2"/>
                 </a:solidFill>
@@ -19305,9 +19791,96 @@
                 <a:ea typeface="Arial" pitchFamily="34" charset="-122"/>
                 <a:cs typeface="Arial" pitchFamily="34" charset="-120"/>
               </a:rPr>
-              <a:t>Zigarette, zerzauste Haare – kein geschöntes Porträt.</a:t>
-            </a:r>
-            <a:endParaRPr lang="en-US" sz="1500" dirty="0"/>
+              <a:t>Nasenspitze und Ohren verschwimmen – Close malt die Unschärfe der Kamera mit.</a:t>
+            </a:r>
+            <a:endParaRPr lang="en-US" sz="1600" dirty="0"/>
+          </a:p>
+        </p:txBody>
+      </p:sp>
+      <p:sp>
+        <p:nvSpPr>
+          <p:cNvPr id="24" name="Shape 21"/>
+          <p:cNvSpPr/>
+          <p:nvPr/>
+        </p:nvSpPr>
+        <p:spPr>
+          <a:xfrm>
+            <a:off x="8587588" y="4617720"/>
+            <a:ext cx="3055468" cy="1325880"/>
+          </a:xfrm>
+          <a:prstGeom prst="rect">
+            <a:avLst/>
+          </a:prstGeom>
+          <a:solidFill>
+            <a:schemeClr val="tx2"/>
+          </a:solidFill>
+          <a:ln w="12700">
+            <a:solidFill>
+              <a:schemeClr val="tx2"/>
+            </a:solidFill>
+            <a:prstDash val="solid"/>
+          </a:ln>
+        </p:spPr>
+      </p:sp>
+      <p:sp>
+        <p:nvSpPr>
+          <p:cNvPr id="25" name="Text 22"/>
+          <p:cNvSpPr txBox="1"/>
+          <p:nvPr/>
+        </p:nvSpPr>
+        <p:spPr>
+          <a:xfrm>
+            <a:off x="8816188" y="4800600"/>
+            <a:ext cx="2598268" cy="1051560"/>
+          </a:xfrm>
+          <a:prstGeom prst="rect">
+            <a:avLst/>
+          </a:prstGeom>
+          <a:noFill/>
+          <a:ln/>
+        </p:spPr>
+        <p:txBody>
+          <a:bodyPr wrap="square" lIns="0" tIns="0" rIns="0" bIns="0" rtlCol="0" anchor="t"/>
+          <a:lstStyle/>
+          <a:p>
+            <a:pPr indent="0" marL="0">
+              <a:spcAft>
+                <a:spcPts val="300"/>
+              </a:spcAft>
+              <a:buNone/>
+            </a:pPr>
+            <a:r>
+              <a:rPr lang="en-US" sz="1600" b="1" dirty="0">
+                <a:solidFill>
+                  <a:schemeClr val="bg1"/>
+                </a:solidFill>
+                <a:latin typeface="Arial" pitchFamily="34" charset="0"/>
+                <a:ea typeface="Arial" pitchFamily="34" charset="-122"/>
+                <a:cs typeface="Arial" pitchFamily="34" charset="-120"/>
+              </a:rPr>
+              <a:t>Schnappschuss</a:t>
+            </a:r>
+            <a:endParaRPr lang="en-US" sz="1600" dirty="0"/>
+          </a:p>
+          <a:p>
+            <a:pPr indent="0" marL="0">
+              <a:spcAft>
+                <a:spcPts val="300"/>
+              </a:spcAft>
+              <a:buNone/>
+            </a:pPr>
+            <a:r>
+              <a:rPr lang="en-US" sz="1400" dirty="0">
+                <a:solidFill>
+                  <a:schemeClr val="bg2"/>
+                </a:solidFill>
+                <a:latin typeface="Arial" pitchFamily="34" charset="0"/>
+                <a:ea typeface="Arial" pitchFamily="34" charset="-122"/>
+                <a:cs typeface="Arial" pitchFamily="34" charset="-120"/>
+              </a:rPr>
+              <a:t>Zigarette, zerzauste Haare, Bartstoppeln – kein geschöntes Porträt.</a:t>
+            </a:r>
+            <a:endParaRPr lang="en-US" sz="1600" dirty="0"/>
           </a:p>
         </p:txBody>
       </p:sp>
@@ -19706,7 +20279,7 @@
                 <a:ea typeface="Arial" pitchFamily="34" charset="-122"/>
                 <a:cs typeface="Arial" pitchFamily="34" charset="-120"/>
               </a:rPr>
-              <a:t>Raster zeichnen oder Dia auf die Leinwand projizieren.</a:t>
+              <a:t>Raster zeichnen oder ein Dia auf die Leinwand projizieren.</a:t>
             </a:r>
             <a:endParaRPr lang="en-US" sz="1700" dirty="0"/>
           </a:p>
@@ -20040,7 +20613,7 @@
                 <a:ea typeface="Arial" pitchFamily="34" charset="-122"/>
                 <a:cs typeface="Arial" pitchFamily="34" charset="-120"/>
               </a:rPr>
-              <a:t>Definition nach Louis K. Meisel (1980) – ein Fotorealist …</a:t>
+              <a:t>Definition nach Louis K. Meisel (formuliert 1972) – ein Fotorealist …</a:t>
             </a:r>
             <a:endParaRPr lang="en-US" sz="1500" dirty="0"/>
           </a:p>

</xml_diff>